<commit_message>
Correct the calibration claim: scorecard beats the trees, not all models
After isotonic recalibration the MLP's ECE (0.0172) is marginally lower
than the scorecard's (0.0175), within seed noise, so the earlier
"best-calibrated model throughout" wording contradicted Table 1, which
correctly bolded the MLP. The defensible claim is that the scorecard has
the best raw calibration and that neither tree ensemble matches it after
recalibration. Fixed in report.tex, report_simple.tex, both memos,
voiceover.tex, README.md and the deck (rebuilt).

Co-Authored-By: Claude Opus 4.8 <noreply@anthropic.com>
</commit_message>
<xml_diff>
--- a/report_and_video/Project_Video_Presentation.pptx
+++ b/report_and_video/Project_Video_Presentation.pptx
@@ -1213,7 +1213,7 @@
           <a:lstStyle/>
           <a:p>
             <a:r>
-              <a:t>Reliability diagrams: raw curves above the diagonal because of vintage drift. Isotonic recalibration on 2014 removes most but not all bias. Scorecard is the best-calibrated model throughout; this is why regulators monitor rather than trust PD models.</a:t>
+              <a:t>Reliability diagrams: raw curves above the diagonal because of vintage drift. Isotonic recalibration on 2014 removes most but not all bias. The trees never match the scorecard on calibration; this is why regulators monitor rather than trust PD models.</a:t>
             </a:r>
           </a:p>
         </p:txBody>
@@ -5268,7 +5268,7 @@
                 </a:solidFill>
                 <a:latin typeface="Calibri"/>
               </a:rPr>
-              <a:t>the MLP loses to the scorecard outright, and the scorecard stays the best-calibrated model throughout.</a:t>
+              <a:t>the MLP loses to the scorecard outright, and the scorecard stays the better calibrated than either tree ensemble.</a:t>
             </a:r>
           </a:p>
           <a:p>
@@ -9558,7 +9558,7 @@
                 </a:solidFill>
                 <a:latin typeface="Calibri"/>
               </a:rPr>
-              <a:t>The scorecard stays best-calibrated:  </a:t>
+              <a:t>The scorecard beats the trees on calibration:  </a:t>
             </a:r>
             <a:r>
               <a:rPr sz="1450" b="0" i="0">

</xml_diff>

<commit_message>
Add ablation slide to the deck and its voiceover block
Deck grows to 13 slides: new slide 11 explains Variant A vs B, the
0.998 installment proxy, and the two findings (scorecard degrades
twice as fast; its IV screen made it immune to the proxy the trees
used). Limitations and wrap-up slides updated to match. Voiceover
gains a 60-second block and is renumbered; total now about 11 minutes.

Co-Authored-By: Claude Opus 4.8 <noreply@anthropic.com>
</commit_message>
<xml_diff>
--- a/report_and_video/Project_Video_Presentation.pptx
+++ b/report_and_video/Project_Video_Presentation.pptx
@@ -17,6 +17,7 @@
     <p:sldId id="265" r:id="rId17"/>
     <p:sldId id="266" r:id="rId18"/>
     <p:sldId id="267" r:id="rId19"/>
+    <p:sldId id="268" r:id="rId20"/>
   </p:sldIdLst>
   <p:sldSz cx="12191695" cy="6858000" type="screen4x3"/>
   <p:notesSz cx="6858000" cy="9144000"/>
@@ -653,7 +654,7 @@
           <a:lstStyle/>
           <a:p>
             <a:r>
-              <a:t>Taiwan reproduces the ranking, so it is not a Lending Club artifact. Then the honest limitations: reject inference, simple cash-flow model, platform grades as features, single benign test vintage.</a:t>
+              <a:t>The honest follow-up experiment. The platform's grade and rate are legitimate inputs for an investor, but they narrow the question. Rerunning without them: every model gets worse, the scorecard worst, so the ML advantage nearly triples. And the scorecard's IV screen had already thrown out the installment proxy that both tree ensembles were quietly using.</a:t>
             </a:r>
           </a:p>
         </p:txBody>
@@ -679,6 +680,76 @@
 </file>
 
 <file path=ppt/notesSlides/notesSlide12.xml><?xml version="1.0" encoding="utf-8"?>
+<p:notes xmlns:a="http://schemas.openxmlformats.org/drawingml/2006/main" xmlns:p="http://schemas.openxmlformats.org/presentationml/2006/main" xmlns:r="http://schemas.openxmlformats.org/officeDocument/2006/relationships">
+  <p:cSld>
+    <p:spTree>
+      <p:nvGrpSpPr>
+        <p:cNvPr id="1" name=""/>
+        <p:cNvGrpSpPr/>
+        <p:nvPr/>
+      </p:nvGrpSpPr>
+      <p:grpSpPr>
+        <a:xfrm>
+          <a:off x="0" y="0"/>
+          <a:ext cx="0" cy="0"/>
+          <a:chOff x="0" y="0"/>
+          <a:chExt cx="0" cy="0"/>
+        </a:xfrm>
+      </p:grpSpPr>
+      <p:sp>
+        <p:nvSpPr>
+          <p:cNvPr id="2" name="Slide Image Placeholder 1"/>
+          <p:cNvSpPr>
+            <a:spLocks noGrp="1"/>
+          </p:cNvSpPr>
+          <p:nvPr>
+            <p:ph type="sldImg" idx="2"/>
+          </p:nvPr>
+        </p:nvSpPr>
+        <p:spPr/>
+      </p:sp>
+      <p:sp>
+        <p:nvSpPr>
+          <p:cNvPr id="3" name="Notes Placeholder 2"/>
+          <p:cNvSpPr>
+            <a:spLocks noGrp="1"/>
+          </p:cNvSpPr>
+          <p:nvPr>
+            <p:ph type="body" idx="3" sz="quarter"/>
+          </p:nvPr>
+        </p:nvSpPr>
+        <p:spPr/>
+        <p:txBody>
+          <a:bodyPr/>
+          <a:lstStyle/>
+          <a:p>
+            <a:r>
+              <a:t>Taiwan reproduces the ranking, so it is not a Lending Club artifact. Then the honest limitations: reject inference, simple cash-flow model, platform grades as features, single benign test vintage.</a:t>
+            </a:r>
+          </a:p>
+        </p:txBody>
+      </p:sp>
+      <p:sp>
+        <p:nvSpPr>
+          <p:cNvPr id="4" name="Slide Number Placeholder 3"/>
+          <p:cNvSpPr>
+            <a:spLocks noGrp="1"/>
+          </p:cNvSpPr>
+          <p:nvPr>
+            <p:ph type="sldNum" idx="5" sz="quarter"/>
+          </p:nvPr>
+        </p:nvSpPr>
+        <p:spPr/>
+      </p:sp>
+    </p:spTree>
+  </p:cSld>
+  <p:clrMapOvr>
+    <a:masterClrMapping/>
+  </p:clrMapOvr>
+</p:notes>
+</file>
+
+<file path=ppt/notesSlides/notesSlide13.xml><?xml version="1.0" encoding="utf-8"?>
 <p:notes xmlns:a="http://schemas.openxmlformats.org/drawingml/2006/main" xmlns:p="http://schemas.openxmlformats.org/presentationml/2006/main" xmlns:r="http://schemas.openxmlformats.org/officeDocument/2006/relationships">
   <p:cSld>
     <p:spTree>
@@ -4601,7 +4672,7 @@
                 </a:solidFill>
                 <a:latin typeface="Calibri"/>
               </a:rPr>
-              <a:t>ROBUSTNESS AND LIMITATIONS</a:t>
+              <a:t>ABLATION</a:t>
             </a:r>
           </a:p>
         </p:txBody>
@@ -4643,21 +4714,72 @@
                 </a:solidFill>
                 <a:latin typeface="Calibri"/>
               </a:rPr>
-              <a:t>Same Ranking on an Independent Dataset</a:t>
-            </a:r>
-          </a:p>
-        </p:txBody>
-      </p:sp>
-      <p:sp>
-        <p:nvSpPr>
-          <p:cNvPr id="4" name="Rounded Rectangle 3"/>
+              <a:t>What If We Hide Lending Club's Own Pricing?</a:t>
+            </a:r>
+          </a:p>
+        </p:txBody>
+      </p:sp>
+      <p:sp>
+        <p:nvSpPr>
+          <p:cNvPr id="4" name="TextBox 3"/>
+          <p:cNvSpPr txBox="1"/>
+          <p:nvPr/>
+        </p:nvSpPr>
+        <p:spPr>
+          <a:xfrm>
+            <a:off x="548640" y="1508760"/>
+            <a:ext cx="11064240" cy="502920"/>
+          </a:xfrm>
+          <a:prstGeom prst="rect">
+            <a:avLst/>
+          </a:prstGeom>
+          <a:noFill/>
+        </p:spPr>
+        <p:txBody>
+          <a:bodyPr wrap="square" anchor="t" lIns="0" rIns="0" tIns="0" bIns="0">
+            <a:spAutoFit/>
+          </a:bodyPr>
+          <a:lstStyle/>
+          <a:p>
+            <a:pPr algn="l">
+              <a:lnSpc>
+                <a:spcPct val="100000"/>
+              </a:lnSpc>
+              <a:spcAft>
+                <a:spcPts val="600"/>
+              </a:spcAft>
+            </a:pPr>
+            <a:r>
+              <a:rPr sz="1450" b="1" i="0">
+                <a:solidFill>
+                  <a:srgbClr val="1B3A6B"/>
+                </a:solidFill>
+                <a:latin typeface="Calibri"/>
+              </a:rPr>
+              <a:t>The concern:  </a:t>
+            </a:r>
+            <a:r>
+              <a:rPr sz="1450" b="0" i="0">
+                <a:solidFill>
+                  <a:srgbClr val="212121"/>
+                </a:solidFill>
+                <a:latin typeface="Calibri"/>
+              </a:rPr>
+              <a:t>grade, sub-grade and interest rate are one variable in three notations, the platform's own risk assessment. They supply 36% of XGBoost's gain and 43% of LightGBM's. So are the models assessing credit risk, or just re-ranking loans Lending Club already ranked?</a:t>
+            </a:r>
+          </a:p>
+        </p:txBody>
+      </p:sp>
+      <p:sp>
+        <p:nvSpPr>
+          <p:cNvPr id="5" name="Rounded Rectangle 4"/>
           <p:cNvSpPr/>
           <p:nvPr/>
         </p:nvSpPr>
         <p:spPr>
           <a:xfrm>
-            <a:off x="548640" y="1691640"/>
-            <a:ext cx="5394960" cy="2377440"/>
+            <a:off x="548640" y="2286000"/>
+            <a:ext cx="5303520" cy="896112"/>
           </a:xfrm>
           <a:prstGeom prst="roundRect">
             <a:avLst>
@@ -4696,14 +4818,14 @@
       </p:sp>
       <p:sp>
         <p:nvSpPr>
-          <p:cNvPr id="5" name="TextBox 4"/>
+          <p:cNvPr id="6" name="TextBox 5"/>
           <p:cNvSpPr txBox="1"/>
           <p:nvPr/>
         </p:nvSpPr>
         <p:spPr>
           <a:xfrm>
-            <a:off x="822960" y="1874519"/>
-            <a:ext cx="4846320" cy="365760"/>
+            <a:off x="822960" y="2404872"/>
+            <a:ext cx="1371600" cy="365760"/>
           </a:xfrm>
           <a:prstGeom prst="rect">
             <a:avLst/>
@@ -4725,27 +4847,27 @@
               </a:spcAft>
             </a:pPr>
             <a:r>
-              <a:rPr sz="1600" b="1" i="0">
-                <a:solidFill>
-                  <a:srgbClr val="1B3A6B"/>
-                </a:solidFill>
-                <a:latin typeface="Calibri"/>
-              </a:rPr>
-              <a:t>UCI Taiwan credit-card default (30k clients)</a:t>
-            </a:r>
-          </a:p>
-        </p:txBody>
-      </p:sp>
-      <p:sp>
-        <p:nvSpPr>
-          <p:cNvPr id="6" name="TextBox 5"/>
+              <a:rPr sz="1500" b="1" i="0">
+                <a:solidFill>
+                  <a:srgbClr val="C99B1C"/>
+                </a:solidFill>
+                <a:latin typeface="Calibri"/>
+              </a:rPr>
+              <a:t>Variant A</a:t>
+            </a:r>
+          </a:p>
+        </p:txBody>
+      </p:sp>
+      <p:sp>
+        <p:nvSpPr>
+          <p:cNvPr id="7" name="TextBox 6"/>
           <p:cNvSpPr txBox="1"/>
           <p:nvPr/>
         </p:nvSpPr>
         <p:spPr>
           <a:xfrm>
-            <a:off x="822960" y="2331720"/>
-            <a:ext cx="4846320" cy="1645920"/>
+            <a:off x="2148840" y="2386584"/>
+            <a:ext cx="3474720" cy="731520"/>
           </a:xfrm>
           <a:prstGeom prst="rect">
             <a:avLst/>
@@ -4763,96 +4885,77 @@
                 <a:spcPct val="100000"/>
               </a:lnSpc>
               <a:spcAft>
-                <a:spcPts val="1000"/>
-              </a:spcAft>
-            </a:pPr>
-            <a:r>
-              <a:rPr sz="1450" b="1" i="0">
-                <a:solidFill>
-                  <a:srgbClr val="1B7A4B"/>
-                </a:solidFill>
-                <a:latin typeface="Calibri"/>
-              </a:rPr>
-              <a:t>XGBoost 0.788</a:t>
-            </a:r>
-            <a:r>
-              <a:rPr sz="1450" b="0" i="0">
+                <a:spcPts val="600"/>
+              </a:spcAft>
+            </a:pPr>
+            <a:r>
+              <a:rPr sz="1200" b="0" i="0">
                 <a:solidFill>
                   <a:srgbClr val="212121"/>
                 </a:solidFill>
                 <a:latin typeface="Calibri"/>
               </a:rPr>
-              <a:t>  vs scorecard 0.772 AUC: +1.50 pts, p = 2.8×10⁻⁶</a:t>
-            </a:r>
-          </a:p>
-          <a:p>
-            <a:pPr algn="l">
-              <a:lnSpc>
-                <a:spcPct val="100000"/>
-              </a:lnSpc>
-              <a:spcAft>
-                <a:spcPts val="1000"/>
-              </a:spcAft>
-            </a:pPr>
-            <a:r>
-              <a:rPr sz="1450" b="1" i="0">
-                <a:solidFill>
-                  <a:srgbClr val="A42A2A"/>
-                </a:solidFill>
-                <a:latin typeface="Calibri"/>
-              </a:rPr>
-              <a:t>MLP 0.766</a:t>
-            </a:r>
-            <a:r>
-              <a:rPr sz="1450" b="0" i="0">
-                <a:solidFill>
-                  <a:srgbClr val="212121"/>
-                </a:solidFill>
-                <a:latin typeface="Calibri"/>
-              </a:rPr>
-              <a:t>  again below the scorecard</a:t>
-            </a:r>
-          </a:p>
-          <a:p>
-            <a:pPr algn="l">
-              <a:lnSpc>
-                <a:spcPct val="100000"/>
-              </a:lnSpc>
-              <a:spcAft>
-                <a:spcPts val="1000"/>
-              </a:spcAft>
-            </a:pPr>
-            <a:r>
-              <a:rPr sz="1450" b="1" i="0">
-                <a:solidFill>
-                  <a:srgbClr val="1B3A6B"/>
-                </a:solidFill>
-                <a:latin typeface="Calibri"/>
-              </a:rPr>
-              <a:t>Scorecard again best ECE</a:t>
-            </a:r>
-            <a:r>
-              <a:rPr sz="1450" b="0" i="0">
-                <a:solidFill>
-                  <a:srgbClr val="212121"/>
-                </a:solidFill>
-                <a:latin typeface="Calibri"/>
-              </a:rPr>
-              <a:t>  after identical recalibration</a:t>
-            </a:r>
-          </a:p>
-        </p:txBody>
-      </p:sp>
-      <p:sp>
-        <p:nvSpPr>
-          <p:cNvPr id="7" name="TextBox 6"/>
+              <a:t>Drop grade, sub-grade, interest rate.  20 features left.</a:t>
+            </a:r>
+          </a:p>
+        </p:txBody>
+      </p:sp>
+      <p:sp>
+        <p:nvSpPr>
+          <p:cNvPr id="8" name="Rounded Rectangle 7"/>
+          <p:cNvSpPr/>
+          <p:nvPr/>
+        </p:nvSpPr>
+        <p:spPr>
+          <a:xfrm>
+            <a:off x="548640" y="3337560"/>
+            <a:ext cx="5303520" cy="896112"/>
+          </a:xfrm>
+          <a:prstGeom prst="roundRect">
+            <a:avLst>
+              <a:gd name="adj" fmla="val 8000"/>
+            </a:avLst>
+          </a:prstGeom>
+          <a:solidFill>
+            <a:srgbClr val="EDF1F7"/>
+          </a:solidFill>
+          <a:ln>
+            <a:noFill/>
+          </a:ln>
+          <a:effectLst/>
+        </p:spPr>
+        <p:style>
+          <a:lnRef idx="1">
+            <a:schemeClr val="accent1"/>
+          </a:lnRef>
+          <a:fillRef idx="3">
+            <a:schemeClr val="accent1"/>
+          </a:fillRef>
+          <a:effectRef idx="2">
+            <a:schemeClr val="accent1"/>
+          </a:effectRef>
+          <a:fontRef idx="minor">
+            <a:schemeClr val="lt1"/>
+          </a:fontRef>
+        </p:style>
+        <p:txBody>
+          <a:bodyPr rtlCol="0" anchor="ctr"/>
+          <a:lstStyle/>
+          <a:p>
+            <a:pPr algn="ctr"/>
+          </a:p>
+        </p:txBody>
+      </p:sp>
+      <p:sp>
+        <p:nvSpPr>
+          <p:cNvPr id="9" name="TextBox 8"/>
           <p:cNvSpPr txBox="1"/>
           <p:nvPr/>
         </p:nvSpPr>
         <p:spPr>
           <a:xfrm>
-            <a:off x="6309360" y="1371600"/>
-            <a:ext cx="5394960" cy="365760"/>
+            <a:off x="822960" y="3456432"/>
+            <a:ext cx="1371600" cy="365760"/>
           </a:xfrm>
           <a:prstGeom prst="rect">
             <a:avLst/>
@@ -4874,27 +4977,27 @@
               </a:spcAft>
             </a:pPr>
             <a:r>
-              <a:rPr sz="1600" b="1" i="0">
-                <a:solidFill>
-                  <a:srgbClr val="1B3A6B"/>
-                </a:solidFill>
-                <a:latin typeface="Calibri"/>
-              </a:rPr>
-              <a:t>Honest limitations</a:t>
-            </a:r>
-          </a:p>
-        </p:txBody>
-      </p:sp>
-      <p:sp>
-        <p:nvSpPr>
-          <p:cNvPr id="8" name="TextBox 7"/>
+              <a:rPr sz="1500" b="1" i="0">
+                <a:solidFill>
+                  <a:srgbClr val="C99B1C"/>
+                </a:solidFill>
+                <a:latin typeface="Calibri"/>
+              </a:rPr>
+              <a:t>Variant B</a:t>
+            </a:r>
+          </a:p>
+        </p:txBody>
+      </p:sp>
+      <p:sp>
+        <p:nvSpPr>
+          <p:cNvPr id="10" name="TextBox 9"/>
           <p:cNvSpPr txBox="1"/>
           <p:nvPr/>
         </p:nvSpPr>
         <p:spPr>
           <a:xfrm>
-            <a:off x="6309360" y="1874519"/>
-            <a:ext cx="5394960" cy="4572000"/>
+            <a:off x="2148840" y="3438144"/>
+            <a:ext cx="3474720" cy="731520"/>
           </a:xfrm>
           <a:prstGeom prst="rect">
             <a:avLst/>
@@ -4909,6 +5012,526 @@
           <a:p>
             <a:pPr algn="l">
               <a:lnSpc>
+                <a:spcPct val="100000"/>
+              </a:lnSpc>
+              <a:spcAft>
+                <a:spcPts val="600"/>
+              </a:spcAft>
+            </a:pPr>
+            <a:r>
+              <a:rPr sz="1200" b="0" i="0">
+                <a:solidFill>
+                  <a:srgbClr val="212121"/>
+                </a:solidFill>
+                <a:latin typeface="Calibri"/>
+              </a:rPr>
+              <a:t>Also drop installment: with the term fixed at 36 months it tracks the rate at ρ = 0.998, so A still leaks pricing through it. B is the honest test.</a:t>
+            </a:r>
+          </a:p>
+        </p:txBody>
+      </p:sp>
+      <p:graphicFrame>
+        <p:nvGraphicFramePr>
+          <p:cNvPr id="11" name="Table 10"/>
+          <p:cNvGraphicFramePr>
+            <a:graphicFrameLocks noGrp="1"/>
+          </p:cNvGraphicFramePr>
+          <p:nvPr/>
+        </p:nvGraphicFramePr>
+        <p:xfrm>
+          <a:off x="6309360" y="2286000"/>
+          <a:ext cx="5303520" cy="2103120"/>
+        </p:xfrm>
+        <a:graphic>
+          <a:graphicData uri="http://schemas.openxmlformats.org/drawingml/2006/table">
+            <a:tbl>
+              <a:tblPr firstRow="1" bandRow="1">
+                <a:tableStyleId>{5C22544A-7EE6-4342-B048-85BDC9FD1C3A}</a:tableStyleId>
+              </a:tblPr>
+              <a:tblGrid>
+                <a:gridCol w="1737360"/>
+                <a:gridCol w="1097280"/>
+                <a:gridCol w="1188720"/>
+                <a:gridCol w="1280160"/>
+              </a:tblGrid>
+              <a:tr h="420624">
+                <a:tc>
+                  <a:txBody>
+                    <a:bodyPr/>
+                    <a:lstStyle/>
+                    <a:p>
+                      <a:r>
+                        <a:rPr b="1" sz="1250">
+                          <a:solidFill>
+                            <a:srgbClr val="FFFFFF"/>
+                          </a:solidFill>
+                          <a:latin typeface="Calibri"/>
+                        </a:rPr>
+                        <a:t>Model</a:t>
+                      </a:r>
+                    </a:p>
+                  </a:txBody>
+                  <a:tcPr>
+                    <a:solidFill>
+                      <a:srgbClr val="1B3A6B"/>
+                    </a:solidFill>
+                  </a:tcPr>
+                </a:tc>
+                <a:tc>
+                  <a:txBody>
+                    <a:bodyPr/>
+                    <a:lstStyle/>
+                    <a:p>
+                      <a:r>
+                        <a:rPr b="1" sz="1250">
+                          <a:solidFill>
+                            <a:srgbClr val="FFFFFF"/>
+                          </a:solidFill>
+                          <a:latin typeface="Calibri"/>
+                        </a:rPr>
+                        <a:t>Baseline</a:t>
+                      </a:r>
+                    </a:p>
+                  </a:txBody>
+                  <a:tcPr>
+                    <a:solidFill>
+                      <a:srgbClr val="1B3A6B"/>
+                    </a:solidFill>
+                  </a:tcPr>
+                </a:tc>
+                <a:tc>
+                  <a:txBody>
+                    <a:bodyPr/>
+                    <a:lstStyle/>
+                    <a:p>
+                      <a:r>
+                        <a:rPr b="1" sz="1250">
+                          <a:solidFill>
+                            <a:srgbClr val="FFFFFF"/>
+                          </a:solidFill>
+                          <a:latin typeface="Calibri"/>
+                        </a:rPr>
+                        <a:t>Variant B</a:t>
+                      </a:r>
+                    </a:p>
+                  </a:txBody>
+                  <a:tcPr>
+                    <a:solidFill>
+                      <a:srgbClr val="1B3A6B"/>
+                    </a:solidFill>
+                  </a:tcPr>
+                </a:tc>
+                <a:tc>
+                  <a:txBody>
+                    <a:bodyPr/>
+                    <a:lstStyle/>
+                    <a:p>
+                      <a:r>
+                        <a:rPr b="1" sz="1250">
+                          <a:solidFill>
+                            <a:srgbClr val="FFFFFF"/>
+                          </a:solidFill>
+                          <a:latin typeface="Calibri"/>
+                        </a:rPr>
+                        <a:t>Change</a:t>
+                      </a:r>
+                    </a:p>
+                  </a:txBody>
+                  <a:tcPr>
+                    <a:solidFill>
+                      <a:srgbClr val="1B3A6B"/>
+                    </a:solidFill>
+                  </a:tcPr>
+                </a:tc>
+              </a:tr>
+              <a:tr h="420624">
+                <a:tc>
+                  <a:txBody>
+                    <a:bodyPr/>
+                    <a:lstStyle/>
+                    <a:p>
+                      <a:r>
+                        <a:rPr sz="1250" b="1">
+                          <a:solidFill>
+                            <a:srgbClr val="212121"/>
+                          </a:solidFill>
+                          <a:latin typeface="Calibri"/>
+                        </a:rPr>
+                        <a:t>XGBoost</a:t>
+                      </a:r>
+                    </a:p>
+                  </a:txBody>
+                  <a:tcPr>
+                    <a:solidFill>
+                      <a:srgbClr val="EDF1F7"/>
+                    </a:solidFill>
+                  </a:tcPr>
+                </a:tc>
+                <a:tc>
+                  <a:txBody>
+                    <a:bodyPr/>
+                    <a:lstStyle/>
+                    <a:p>
+                      <a:r>
+                        <a:rPr sz="1250" b="0">
+                          <a:solidFill>
+                            <a:srgbClr val="212121"/>
+                          </a:solidFill>
+                          <a:latin typeface="Calibri"/>
+                        </a:rPr>
+                        <a:t>0.6850</a:t>
+                      </a:r>
+                    </a:p>
+                  </a:txBody>
+                  <a:tcPr>
+                    <a:solidFill>
+                      <a:srgbClr val="EDF1F7"/>
+                    </a:solidFill>
+                  </a:tcPr>
+                </a:tc>
+                <a:tc>
+                  <a:txBody>
+                    <a:bodyPr/>
+                    <a:lstStyle/>
+                    <a:p>
+                      <a:r>
+                        <a:rPr sz="1250" b="0">
+                          <a:solidFill>
+                            <a:srgbClr val="212121"/>
+                          </a:solidFill>
+                          <a:latin typeface="Calibri"/>
+                        </a:rPr>
+                        <a:t>0.6637</a:t>
+                      </a:r>
+                    </a:p>
+                  </a:txBody>
+                  <a:tcPr>
+                    <a:solidFill>
+                      <a:srgbClr val="EDF1F7"/>
+                    </a:solidFill>
+                  </a:tcPr>
+                </a:tc>
+                <a:tc>
+                  <a:txBody>
+                    <a:bodyPr/>
+                    <a:lstStyle/>
+                    <a:p>
+                      <a:r>
+                        <a:rPr sz="1250" b="0">
+                          <a:solidFill>
+                            <a:srgbClr val="212121"/>
+                          </a:solidFill>
+                          <a:latin typeface="Calibri"/>
+                        </a:rPr>
+                        <a:t>−0.021</a:t>
+                      </a:r>
+                    </a:p>
+                  </a:txBody>
+                  <a:tcPr>
+                    <a:solidFill>
+                      <a:srgbClr val="EDF1F7"/>
+                    </a:solidFill>
+                  </a:tcPr>
+                </a:tc>
+              </a:tr>
+              <a:tr h="420624">
+                <a:tc>
+                  <a:txBody>
+                    <a:bodyPr/>
+                    <a:lstStyle/>
+                    <a:p>
+                      <a:r>
+                        <a:rPr sz="1250" b="1">
+                          <a:solidFill>
+                            <a:srgbClr val="212121"/>
+                          </a:solidFill>
+                          <a:latin typeface="Calibri"/>
+                        </a:rPr>
+                        <a:t>LightGBM</a:t>
+                      </a:r>
+                    </a:p>
+                  </a:txBody>
+                  <a:tcPr>
+                    <a:solidFill>
+                      <a:srgbClr val="FFFFFF"/>
+                    </a:solidFill>
+                  </a:tcPr>
+                </a:tc>
+                <a:tc>
+                  <a:txBody>
+                    <a:bodyPr/>
+                    <a:lstStyle/>
+                    <a:p>
+                      <a:r>
+                        <a:rPr sz="1250" b="0">
+                          <a:solidFill>
+                            <a:srgbClr val="212121"/>
+                          </a:solidFill>
+                          <a:latin typeface="Calibri"/>
+                        </a:rPr>
+                        <a:t>0.6843</a:t>
+                      </a:r>
+                    </a:p>
+                  </a:txBody>
+                  <a:tcPr>
+                    <a:solidFill>
+                      <a:srgbClr val="FFFFFF"/>
+                    </a:solidFill>
+                  </a:tcPr>
+                </a:tc>
+                <a:tc>
+                  <a:txBody>
+                    <a:bodyPr/>
+                    <a:lstStyle/>
+                    <a:p>
+                      <a:r>
+                        <a:rPr sz="1250" b="0">
+                          <a:solidFill>
+                            <a:srgbClr val="212121"/>
+                          </a:solidFill>
+                          <a:latin typeface="Calibri"/>
+                        </a:rPr>
+                        <a:t>0.6622</a:t>
+                      </a:r>
+                    </a:p>
+                  </a:txBody>
+                  <a:tcPr>
+                    <a:solidFill>
+                      <a:srgbClr val="FFFFFF"/>
+                    </a:solidFill>
+                  </a:tcPr>
+                </a:tc>
+                <a:tc>
+                  <a:txBody>
+                    <a:bodyPr/>
+                    <a:lstStyle/>
+                    <a:p>
+                      <a:r>
+                        <a:rPr sz="1250" b="0">
+                          <a:solidFill>
+                            <a:srgbClr val="212121"/>
+                          </a:solidFill>
+                          <a:latin typeface="Calibri"/>
+                        </a:rPr>
+                        <a:t>−0.022</a:t>
+                      </a:r>
+                    </a:p>
+                  </a:txBody>
+                  <a:tcPr>
+                    <a:solidFill>
+                      <a:srgbClr val="FFFFFF"/>
+                    </a:solidFill>
+                  </a:tcPr>
+                </a:tc>
+              </a:tr>
+              <a:tr h="420624">
+                <a:tc>
+                  <a:txBody>
+                    <a:bodyPr/>
+                    <a:lstStyle/>
+                    <a:p>
+                      <a:r>
+                        <a:rPr sz="1250" b="1">
+                          <a:solidFill>
+                            <a:srgbClr val="212121"/>
+                          </a:solidFill>
+                          <a:latin typeface="Calibri"/>
+                        </a:rPr>
+                        <a:t>MLP</a:t>
+                      </a:r>
+                    </a:p>
+                  </a:txBody>
+                  <a:tcPr>
+                    <a:solidFill>
+                      <a:srgbClr val="EDF1F7"/>
+                    </a:solidFill>
+                  </a:tcPr>
+                </a:tc>
+                <a:tc>
+                  <a:txBody>
+                    <a:bodyPr/>
+                    <a:lstStyle/>
+                    <a:p>
+                      <a:r>
+                        <a:rPr sz="1250" b="0">
+                          <a:solidFill>
+                            <a:srgbClr val="212121"/>
+                          </a:solidFill>
+                          <a:latin typeface="Calibri"/>
+                        </a:rPr>
+                        <a:t>0.6716</a:t>
+                      </a:r>
+                    </a:p>
+                  </a:txBody>
+                  <a:tcPr>
+                    <a:solidFill>
+                      <a:srgbClr val="EDF1F7"/>
+                    </a:solidFill>
+                  </a:tcPr>
+                </a:tc>
+                <a:tc>
+                  <a:txBody>
+                    <a:bodyPr/>
+                    <a:lstStyle/>
+                    <a:p>
+                      <a:r>
+                        <a:rPr sz="1250" b="0">
+                          <a:solidFill>
+                            <a:srgbClr val="212121"/>
+                          </a:solidFill>
+                          <a:latin typeface="Calibri"/>
+                        </a:rPr>
+                        <a:t>0.6428</a:t>
+                      </a:r>
+                    </a:p>
+                  </a:txBody>
+                  <a:tcPr>
+                    <a:solidFill>
+                      <a:srgbClr val="EDF1F7"/>
+                    </a:solidFill>
+                  </a:tcPr>
+                </a:tc>
+                <a:tc>
+                  <a:txBody>
+                    <a:bodyPr/>
+                    <a:lstStyle/>
+                    <a:p>
+                      <a:r>
+                        <a:rPr sz="1250" b="0">
+                          <a:solidFill>
+                            <a:srgbClr val="212121"/>
+                          </a:solidFill>
+                          <a:latin typeface="Calibri"/>
+                        </a:rPr>
+                        <a:t>−0.029</a:t>
+                      </a:r>
+                    </a:p>
+                  </a:txBody>
+                  <a:tcPr>
+                    <a:solidFill>
+                      <a:srgbClr val="EDF1F7"/>
+                    </a:solidFill>
+                  </a:tcPr>
+                </a:tc>
+              </a:tr>
+              <a:tr h="420624">
+                <a:tc>
+                  <a:txBody>
+                    <a:bodyPr/>
+                    <a:lstStyle/>
+                    <a:p>
+                      <a:r>
+                        <a:rPr sz="1250" b="1">
+                          <a:solidFill>
+                            <a:srgbClr val="212121"/>
+                          </a:solidFill>
+                          <a:latin typeface="Calibri"/>
+                        </a:rPr>
+                        <a:t>Scorecard</a:t>
+                      </a:r>
+                    </a:p>
+                  </a:txBody>
+                  <a:tcPr>
+                    <a:solidFill>
+                      <a:srgbClr val="FFFFFF"/>
+                    </a:solidFill>
+                  </a:tcPr>
+                </a:tc>
+                <a:tc>
+                  <a:txBody>
+                    <a:bodyPr/>
+                    <a:lstStyle/>
+                    <a:p>
+                      <a:r>
+                        <a:rPr sz="1250" b="0">
+                          <a:solidFill>
+                            <a:srgbClr val="212121"/>
+                          </a:solidFill>
+                          <a:latin typeface="Calibri"/>
+                        </a:rPr>
+                        <a:t>0.6767</a:t>
+                      </a:r>
+                    </a:p>
+                  </a:txBody>
+                  <a:tcPr>
+                    <a:solidFill>
+                      <a:srgbClr val="FFFFFF"/>
+                    </a:solidFill>
+                  </a:tcPr>
+                </a:tc>
+                <a:tc>
+                  <a:txBody>
+                    <a:bodyPr/>
+                    <a:lstStyle/>
+                    <a:p>
+                      <a:r>
+                        <a:rPr sz="1250" b="0">
+                          <a:solidFill>
+                            <a:srgbClr val="212121"/>
+                          </a:solidFill>
+                          <a:latin typeface="Calibri"/>
+                        </a:rPr>
+                        <a:t>0.6397</a:t>
+                      </a:r>
+                    </a:p>
+                  </a:txBody>
+                  <a:tcPr>
+                    <a:solidFill>
+                      <a:srgbClr val="FFFFFF"/>
+                    </a:solidFill>
+                  </a:tcPr>
+                </a:tc>
+                <a:tc>
+                  <a:txBody>
+                    <a:bodyPr/>
+                    <a:lstStyle/>
+                    <a:p>
+                      <a:r>
+                        <a:rPr sz="1250" b="0">
+                          <a:solidFill>
+                            <a:srgbClr val="A42A2A"/>
+                          </a:solidFill>
+                          <a:latin typeface="Calibri"/>
+                        </a:rPr>
+                        <a:t>−0.037</a:t>
+                      </a:r>
+                    </a:p>
+                  </a:txBody>
+                  <a:tcPr>
+                    <a:solidFill>
+                      <a:srgbClr val="FFFFFF"/>
+                    </a:solidFill>
+                  </a:tcPr>
+                </a:tc>
+              </a:tr>
+            </a:tbl>
+          </a:graphicData>
+        </a:graphic>
+      </p:graphicFrame>
+      <p:sp>
+        <p:nvSpPr>
+          <p:cNvPr id="12" name="TextBox 11"/>
+          <p:cNvSpPr txBox="1"/>
+          <p:nvPr/>
+        </p:nvSpPr>
+        <p:spPr>
+          <a:xfrm>
+            <a:off x="548640" y="4617720"/>
+            <a:ext cx="11064240" cy="1920240"/>
+          </a:xfrm>
+          <a:prstGeom prst="rect">
+            <a:avLst/>
+          </a:prstGeom>
+          <a:noFill/>
+        </p:spPr>
+        <p:txBody>
+          <a:bodyPr wrap="square" anchor="t" lIns="0" rIns="0" tIns="0" bIns="0">
+            <a:spAutoFit/>
+          </a:bodyPr>
+          <a:lstStyle/>
+          <a:p>
+            <a:pPr algn="l">
+              <a:lnSpc>
                 <a:spcPct val="105000"/>
               </a:lnSpc>
               <a:spcAft>
@@ -4922,7 +5545,7 @@
                 </a:solidFill>
                 <a:latin typeface="Calibri"/>
               </a:rPr>
-              <a:t>Accepted loans only:  </a:t>
+              <a:t>The pricing was hiding the ML advantage, not creating it:  </a:t>
             </a:r>
             <a:r>
               <a:rPr sz="1400" b="0" i="0">
@@ -4931,7 +5554,7 @@
                 </a:solidFill>
                 <a:latin typeface="Calibri"/>
               </a:rPr>
-              <a:t>all models inherit Lending Club's own selection; reject inference is an open problem.</a:t>
+              <a:t>the scorecard degrades almost twice as fast as the trees, so XGBoost's lead grows from +0.83 to +2.39 AUC points, and its profit edge to $15,400 per 1,000 applicants.</a:t>
             </a:r>
           </a:p>
           <a:p>
@@ -4950,7 +5573,7 @@
                 </a:solidFill>
                 <a:latin typeface="Calibri"/>
               </a:rPr>
-              <a:t>Simple profit model:  </a:t>
+              <a:t>The trees used the proxy; the scorecard could not:  </a:t>
             </a:r>
             <a:r>
               <a:rPr sz="1400" b="0" i="0">
@@ -4959,91 +5582,7 @@
                 </a:solidFill>
                 <a:latin typeface="Calibri"/>
               </a:rPr>
-              <a:t>undiscounted, fixed LGD of 0.65, no partial recoveries or prepayment.</a:t>
-            </a:r>
-          </a:p>
-          <a:p>
-            <a:pPr algn="l">
-              <a:lnSpc>
-                <a:spcPct val="105000"/>
-              </a:lnSpc>
-              <a:spcAft>
-                <a:spcPts val="900"/>
-              </a:spcAft>
-            </a:pPr>
-            <a:r>
-              <a:rPr sz="1400" b="1" i="0">
-                <a:solidFill>
-                  <a:srgbClr val="1B3A6B"/>
-                </a:solidFill>
-                <a:latin typeface="Calibri"/>
-              </a:rPr>
-              <a:t>Platform grades kept as features:  </a:t>
-            </a:r>
-            <a:r>
-              <a:rPr sz="1400" b="0" i="0">
-                <a:solidFill>
-                  <a:srgbClr val="212121"/>
-                </a:solidFill>
-                <a:latin typeface="Calibri"/>
-              </a:rPr>
-              <a:t>realistic for an investor, but understates what ML could add on raw bureau data.</a:t>
-            </a:r>
-          </a:p>
-          <a:p>
-            <a:pPr algn="l">
-              <a:lnSpc>
-                <a:spcPct val="105000"/>
-              </a:lnSpc>
-              <a:spcAft>
-                <a:spcPts val="900"/>
-              </a:spcAft>
-            </a:pPr>
-            <a:r>
-              <a:rPr sz="1400" b="1" i="0">
-                <a:solidFill>
-                  <a:srgbClr val="1B3A6B"/>
-                </a:solidFill>
-                <a:latin typeface="Calibri"/>
-              </a:rPr>
-              <a:t>One market, one test vintage:  </a:t>
-            </a:r>
-            <a:r>
-              <a:rPr sz="1400" b="0" i="0">
-                <a:solidFill>
-                  <a:srgbClr val="212121"/>
-                </a:solidFill>
-                <a:latin typeface="Calibri"/>
-              </a:rPr>
-              <a:t>2015 was benign; a recession vintage could reorder the calibration findings.</a:t>
-            </a:r>
-          </a:p>
-          <a:p>
-            <a:pPr algn="l">
-              <a:lnSpc>
-                <a:spcPct val="105000"/>
-              </a:lnSpc>
-              <a:spcAft>
-                <a:spcPts val="900"/>
-              </a:spcAft>
-            </a:pPr>
-            <a:r>
-              <a:rPr sz="1400" b="1" i="0">
-                <a:solidFill>
-                  <a:srgbClr val="1B3A6B"/>
-                </a:solidFill>
-                <a:latin typeface="Calibri"/>
-              </a:rPr>
-              <a:t>My scorecard is unconstrained:  </a:t>
-            </a:r>
-            <a:r>
-              <a:rPr sz="1400" b="0" i="0">
-                <a:solidFill>
-                  <a:srgbClr val="212121"/>
-                </a:solidFill>
-                <a:latin typeface="Calibri"/>
-              </a:rPr>
-              <a:t>expert binning with monotonicity constraints would likely close part of the gap.</a:t>
+              <a:t>the scorecard scores 0.6397 under both variants because its information-value screen had already discarded installment as too weak. The old-fashioned screen was the protection.</a:t>
             </a:r>
           </a:p>
         </p:txBody>
@@ -5068,20 +5607,106 @@
       <p:grpSpPr/>
       <p:sp>
         <p:nvSpPr>
-          <p:cNvPr id="2" name="Rectangle 1"/>
-          <p:cNvSpPr/>
+          <p:cNvPr id="2" name="TextBox 1"/>
+          <p:cNvSpPr txBox="1"/>
           <p:nvPr/>
         </p:nvSpPr>
         <p:spPr>
           <a:xfrm>
-            <a:off x="0" y="0"/>
-            <a:ext cx="12191695" cy="6858000"/>
+            <a:off x="548640" y="347472"/>
+            <a:ext cx="11064240" cy="274320"/>
           </a:xfrm>
           <a:prstGeom prst="rect">
             <a:avLst/>
           </a:prstGeom>
+          <a:noFill/>
+        </p:spPr>
+        <p:txBody>
+          <a:bodyPr wrap="square" anchor="t" lIns="0" rIns="0" tIns="0" bIns="0">
+            <a:spAutoFit/>
+          </a:bodyPr>
+          <a:lstStyle/>
+          <a:p>
+            <a:pPr algn="l">
+              <a:lnSpc>
+                <a:spcPct val="100000"/>
+              </a:lnSpc>
+              <a:spcAft>
+                <a:spcPts val="600"/>
+              </a:spcAft>
+            </a:pPr>
+            <a:r>
+              <a:rPr sz="1300" b="1" i="0">
+                <a:solidFill>
+                  <a:srgbClr val="C99B1C"/>
+                </a:solidFill>
+                <a:latin typeface="Calibri"/>
+              </a:rPr>
+              <a:t>ROBUSTNESS AND LIMITATIONS</a:t>
+            </a:r>
+          </a:p>
+        </p:txBody>
+      </p:sp>
+      <p:sp>
+        <p:nvSpPr>
+          <p:cNvPr id="3" name="TextBox 2"/>
+          <p:cNvSpPr txBox="1"/>
+          <p:nvPr/>
+        </p:nvSpPr>
+        <p:spPr>
+          <a:xfrm>
+            <a:off x="548640" y="621792"/>
+            <a:ext cx="11064240" cy="685800"/>
+          </a:xfrm>
+          <a:prstGeom prst="rect">
+            <a:avLst/>
+          </a:prstGeom>
+          <a:noFill/>
+        </p:spPr>
+        <p:txBody>
+          <a:bodyPr wrap="square" anchor="t" lIns="0" rIns="0" tIns="0" bIns="0">
+            <a:spAutoFit/>
+          </a:bodyPr>
+          <a:lstStyle/>
+          <a:p>
+            <a:pPr algn="l">
+              <a:lnSpc>
+                <a:spcPct val="100000"/>
+              </a:lnSpc>
+              <a:spcAft>
+                <a:spcPts val="600"/>
+              </a:spcAft>
+            </a:pPr>
+            <a:r>
+              <a:rPr sz="3200" b="1" i="0">
+                <a:solidFill>
+                  <a:srgbClr val="1B3A6B"/>
+                </a:solidFill>
+                <a:latin typeface="Calibri"/>
+              </a:rPr>
+              <a:t>Same Ranking on an Independent Dataset</a:t>
+            </a:r>
+          </a:p>
+        </p:txBody>
+      </p:sp>
+      <p:sp>
+        <p:nvSpPr>
+          <p:cNvPr id="4" name="Rounded Rectangle 3"/>
+          <p:cNvSpPr/>
+          <p:nvPr/>
+        </p:nvSpPr>
+        <p:spPr>
+          <a:xfrm>
+            <a:off x="548640" y="1691640"/>
+            <a:ext cx="5394960" cy="2377440"/>
+          </a:xfrm>
+          <a:prstGeom prst="roundRect">
+            <a:avLst>
+              <a:gd name="adj" fmla="val 8000"/>
+            </a:avLst>
+          </a:prstGeom>
           <a:solidFill>
-            <a:srgbClr val="1B3A6B"/>
+            <a:srgbClr val="EDF1F7"/>
           </a:solidFill>
           <a:ln>
             <a:noFill/>
@@ -5112,14 +5737,14 @@
       </p:sp>
       <p:sp>
         <p:nvSpPr>
-          <p:cNvPr id="3" name="TextBox 2"/>
+          <p:cNvPr id="5" name="TextBox 4"/>
           <p:cNvSpPr txBox="1"/>
           <p:nvPr/>
         </p:nvSpPr>
         <p:spPr>
           <a:xfrm>
-            <a:off x="731520" y="502920"/>
-            <a:ext cx="10698480" cy="320040"/>
+            <a:off x="822960" y="1874519"/>
+            <a:ext cx="4846320" cy="365760"/>
           </a:xfrm>
           <a:prstGeom prst="rect">
             <a:avLst/>
@@ -5141,27 +5766,27 @@
               </a:spcAft>
             </a:pPr>
             <a:r>
-              <a:rPr sz="1300" b="1" i="0">
-                <a:solidFill>
-                  <a:srgbClr val="C99B1C"/>
-                </a:solidFill>
-                <a:latin typeface="Calibri"/>
-              </a:rPr>
-              <a:t>WRAP-UP</a:t>
-            </a:r>
-          </a:p>
-        </p:txBody>
-      </p:sp>
-      <p:sp>
-        <p:nvSpPr>
-          <p:cNvPr id="4" name="TextBox 3"/>
+              <a:rPr sz="1600" b="1" i="0">
+                <a:solidFill>
+                  <a:srgbClr val="1B3A6B"/>
+                </a:solidFill>
+                <a:latin typeface="Calibri"/>
+              </a:rPr>
+              <a:t>UCI Taiwan credit-card default (30k clients)</a:t>
+            </a:r>
+          </a:p>
+        </p:txBody>
+      </p:sp>
+      <p:sp>
+        <p:nvSpPr>
+          <p:cNvPr id="6" name="TextBox 5"/>
           <p:cNvSpPr txBox="1"/>
           <p:nvPr/>
         </p:nvSpPr>
         <p:spPr>
           <a:xfrm>
-            <a:off x="731520" y="868680"/>
-            <a:ext cx="10698480" cy="1280160"/>
+            <a:off x="822960" y="2331720"/>
+            <a:ext cx="4846320" cy="1645920"/>
           </a:xfrm>
           <a:prstGeom prst="rect">
             <a:avLst/>
@@ -5179,31 +5804,96 @@
                 <a:spcPct val="100000"/>
               </a:lnSpc>
               <a:spcAft>
-                <a:spcPts val="600"/>
-              </a:spcAft>
-            </a:pPr>
-            <a:r>
-              <a:rPr sz="3100" b="1" i="0">
-                <a:solidFill>
-                  <a:srgbClr val="FFFFFF"/>
-                </a:solidFill>
-                <a:latin typeface="Calibri"/>
-              </a:rPr>
-              <a:t>A Qualified Yes: ML Wins, but Narrowly, and Only the Trees</a:t>
-            </a:r>
-          </a:p>
-        </p:txBody>
-      </p:sp>
-      <p:sp>
-        <p:nvSpPr>
-          <p:cNvPr id="5" name="TextBox 4"/>
+                <a:spcPts val="1000"/>
+              </a:spcAft>
+            </a:pPr>
+            <a:r>
+              <a:rPr sz="1450" b="1" i="0">
+                <a:solidFill>
+                  <a:srgbClr val="1B7A4B"/>
+                </a:solidFill>
+                <a:latin typeface="Calibri"/>
+              </a:rPr>
+              <a:t>XGBoost 0.788</a:t>
+            </a:r>
+            <a:r>
+              <a:rPr sz="1450" b="0" i="0">
+                <a:solidFill>
+                  <a:srgbClr val="212121"/>
+                </a:solidFill>
+                <a:latin typeface="Calibri"/>
+              </a:rPr>
+              <a:t>  vs scorecard 0.772 AUC: +1.50 pts, p = 2.8×10⁻⁶</a:t>
+            </a:r>
+          </a:p>
+          <a:p>
+            <a:pPr algn="l">
+              <a:lnSpc>
+                <a:spcPct val="100000"/>
+              </a:lnSpc>
+              <a:spcAft>
+                <a:spcPts val="1000"/>
+              </a:spcAft>
+            </a:pPr>
+            <a:r>
+              <a:rPr sz="1450" b="1" i="0">
+                <a:solidFill>
+                  <a:srgbClr val="A42A2A"/>
+                </a:solidFill>
+                <a:latin typeface="Calibri"/>
+              </a:rPr>
+              <a:t>MLP 0.766</a:t>
+            </a:r>
+            <a:r>
+              <a:rPr sz="1450" b="0" i="0">
+                <a:solidFill>
+                  <a:srgbClr val="212121"/>
+                </a:solidFill>
+                <a:latin typeface="Calibri"/>
+              </a:rPr>
+              <a:t>  again below the scorecard</a:t>
+            </a:r>
+          </a:p>
+          <a:p>
+            <a:pPr algn="l">
+              <a:lnSpc>
+                <a:spcPct val="100000"/>
+              </a:lnSpc>
+              <a:spcAft>
+                <a:spcPts val="1000"/>
+              </a:spcAft>
+            </a:pPr>
+            <a:r>
+              <a:rPr sz="1450" b="1" i="0">
+                <a:solidFill>
+                  <a:srgbClr val="1B3A6B"/>
+                </a:solidFill>
+                <a:latin typeface="Calibri"/>
+              </a:rPr>
+              <a:t>Scorecard again best ECE</a:t>
+            </a:r>
+            <a:r>
+              <a:rPr sz="1450" b="0" i="0">
+                <a:solidFill>
+                  <a:srgbClr val="212121"/>
+                </a:solidFill>
+                <a:latin typeface="Calibri"/>
+              </a:rPr>
+              <a:t>  after identical recalibration</a:t>
+            </a:r>
+          </a:p>
+        </p:txBody>
+      </p:sp>
+      <p:sp>
+        <p:nvSpPr>
+          <p:cNvPr id="7" name="TextBox 6"/>
           <p:cNvSpPr txBox="1"/>
           <p:nvPr/>
         </p:nvSpPr>
         <p:spPr>
           <a:xfrm>
-            <a:off x="731520" y="1965960"/>
-            <a:ext cx="10698480" cy="2651760"/>
+            <a:off x="6309360" y="1371600"/>
+            <a:ext cx="5394960" cy="365760"/>
           </a:xfrm>
           <a:prstGeom prst="rect">
             <a:avLst/>
@@ -5218,6 +5908,357 @@
           <a:p>
             <a:pPr algn="l">
               <a:lnSpc>
+                <a:spcPct val="100000"/>
+              </a:lnSpc>
+              <a:spcAft>
+                <a:spcPts val="600"/>
+              </a:spcAft>
+            </a:pPr>
+            <a:r>
+              <a:rPr sz="1600" b="1" i="0">
+                <a:solidFill>
+                  <a:srgbClr val="1B3A6B"/>
+                </a:solidFill>
+                <a:latin typeface="Calibri"/>
+              </a:rPr>
+              <a:t>Honest limitations</a:t>
+            </a:r>
+          </a:p>
+        </p:txBody>
+      </p:sp>
+      <p:sp>
+        <p:nvSpPr>
+          <p:cNvPr id="8" name="TextBox 7"/>
+          <p:cNvSpPr txBox="1"/>
+          <p:nvPr/>
+        </p:nvSpPr>
+        <p:spPr>
+          <a:xfrm>
+            <a:off x="6309360" y="1874519"/>
+            <a:ext cx="5394960" cy="4572000"/>
+          </a:xfrm>
+          <a:prstGeom prst="rect">
+            <a:avLst/>
+          </a:prstGeom>
+          <a:noFill/>
+        </p:spPr>
+        <p:txBody>
+          <a:bodyPr wrap="square" anchor="t" lIns="0" rIns="0" tIns="0" bIns="0">
+            <a:spAutoFit/>
+          </a:bodyPr>
+          <a:lstStyle/>
+          <a:p>
+            <a:pPr algn="l">
+              <a:lnSpc>
+                <a:spcPct val="105000"/>
+              </a:lnSpc>
+              <a:spcAft>
+                <a:spcPts val="900"/>
+              </a:spcAft>
+            </a:pPr>
+            <a:r>
+              <a:rPr sz="1400" b="1" i="0">
+                <a:solidFill>
+                  <a:srgbClr val="1B3A6B"/>
+                </a:solidFill>
+                <a:latin typeface="Calibri"/>
+              </a:rPr>
+              <a:t>Accepted loans only:  </a:t>
+            </a:r>
+            <a:r>
+              <a:rPr sz="1400" b="0" i="0">
+                <a:solidFill>
+                  <a:srgbClr val="212121"/>
+                </a:solidFill>
+                <a:latin typeface="Calibri"/>
+              </a:rPr>
+              <a:t>all models inherit Lending Club's own selection; reject inference is an open problem.</a:t>
+            </a:r>
+          </a:p>
+          <a:p>
+            <a:pPr algn="l">
+              <a:lnSpc>
+                <a:spcPct val="105000"/>
+              </a:lnSpc>
+              <a:spcAft>
+                <a:spcPts val="900"/>
+              </a:spcAft>
+            </a:pPr>
+            <a:r>
+              <a:rPr sz="1400" b="1" i="0">
+                <a:solidFill>
+                  <a:srgbClr val="1B3A6B"/>
+                </a:solidFill>
+                <a:latin typeface="Calibri"/>
+              </a:rPr>
+              <a:t>Simple profit model:  </a:t>
+            </a:r>
+            <a:r>
+              <a:rPr sz="1400" b="0" i="0">
+                <a:solidFill>
+                  <a:srgbClr val="212121"/>
+                </a:solidFill>
+                <a:latin typeface="Calibri"/>
+              </a:rPr>
+              <a:t>undiscounted, fixed LGD of 0.65, no partial recoveries or prepayment.</a:t>
+            </a:r>
+          </a:p>
+          <a:p>
+            <a:pPr algn="l">
+              <a:lnSpc>
+                <a:spcPct val="105000"/>
+              </a:lnSpc>
+              <a:spcAft>
+                <a:spcPts val="900"/>
+              </a:spcAft>
+            </a:pPr>
+            <a:r>
+              <a:rPr sz="1400" b="1" i="0">
+                <a:solidFill>
+                  <a:srgbClr val="1B3A6B"/>
+                </a:solidFill>
+                <a:latin typeface="Calibri"/>
+              </a:rPr>
+              <a:t>Platform grades kept as features:  </a:t>
+            </a:r>
+            <a:r>
+              <a:rPr sz="1400" b="0" i="0">
+                <a:solidFill>
+                  <a:srgbClr val="212121"/>
+                </a:solidFill>
+                <a:latin typeface="Calibri"/>
+              </a:rPr>
+              <a:t>realistic for an investor; the ablation shows this understates the ML advantage by about 3x.</a:t>
+            </a:r>
+          </a:p>
+          <a:p>
+            <a:pPr algn="l">
+              <a:lnSpc>
+                <a:spcPct val="105000"/>
+              </a:lnSpc>
+              <a:spcAft>
+                <a:spcPts val="900"/>
+              </a:spcAft>
+            </a:pPr>
+            <a:r>
+              <a:rPr sz="1400" b="1" i="0">
+                <a:solidFill>
+                  <a:srgbClr val="1B3A6B"/>
+                </a:solidFill>
+                <a:latin typeface="Calibri"/>
+              </a:rPr>
+              <a:t>One market, one test vintage:  </a:t>
+            </a:r>
+            <a:r>
+              <a:rPr sz="1400" b="0" i="0">
+                <a:solidFill>
+                  <a:srgbClr val="212121"/>
+                </a:solidFill>
+                <a:latin typeface="Calibri"/>
+              </a:rPr>
+              <a:t>2015 was benign; a recession vintage could reorder the calibration findings.</a:t>
+            </a:r>
+          </a:p>
+          <a:p>
+            <a:pPr algn="l">
+              <a:lnSpc>
+                <a:spcPct val="105000"/>
+              </a:lnSpc>
+              <a:spcAft>
+                <a:spcPts val="900"/>
+              </a:spcAft>
+            </a:pPr>
+            <a:r>
+              <a:rPr sz="1400" b="1" i="0">
+                <a:solidFill>
+                  <a:srgbClr val="1B3A6B"/>
+                </a:solidFill>
+                <a:latin typeface="Calibri"/>
+              </a:rPr>
+              <a:t>My scorecard is unconstrained:  </a:t>
+            </a:r>
+            <a:r>
+              <a:rPr sz="1400" b="0" i="0">
+                <a:solidFill>
+                  <a:srgbClr val="212121"/>
+                </a:solidFill>
+                <a:latin typeface="Calibri"/>
+              </a:rPr>
+              <a:t>expert binning with monotonicity constraints would likely close part of the gap.</a:t>
+            </a:r>
+          </a:p>
+        </p:txBody>
+      </p:sp>
+    </p:spTree>
+  </p:cSld>
+  <p:clrMapOvr>
+    <a:masterClrMapping/>
+  </p:clrMapOvr>
+</p:sld>
+</file>
+
+<file path=ppt/slides/slide13.xml><?xml version="1.0" encoding="utf-8"?>
+<p:sld xmlns:a="http://schemas.openxmlformats.org/drawingml/2006/main" xmlns:p="http://schemas.openxmlformats.org/presentationml/2006/main" xmlns:r="http://schemas.openxmlformats.org/officeDocument/2006/relationships">
+  <p:cSld>
+    <p:spTree>
+      <p:nvGrpSpPr>
+        <p:cNvPr id="1" name=""/>
+        <p:cNvGrpSpPr/>
+        <p:nvPr/>
+      </p:nvGrpSpPr>
+      <p:grpSpPr/>
+      <p:sp>
+        <p:nvSpPr>
+          <p:cNvPr id="2" name="Rectangle 1"/>
+          <p:cNvSpPr/>
+          <p:nvPr/>
+        </p:nvSpPr>
+        <p:spPr>
+          <a:xfrm>
+            <a:off x="0" y="0"/>
+            <a:ext cx="12191695" cy="6858000"/>
+          </a:xfrm>
+          <a:prstGeom prst="rect">
+            <a:avLst/>
+          </a:prstGeom>
+          <a:solidFill>
+            <a:srgbClr val="1B3A6B"/>
+          </a:solidFill>
+          <a:ln>
+            <a:noFill/>
+          </a:ln>
+          <a:effectLst/>
+        </p:spPr>
+        <p:style>
+          <a:lnRef idx="1">
+            <a:schemeClr val="accent1"/>
+          </a:lnRef>
+          <a:fillRef idx="3">
+            <a:schemeClr val="accent1"/>
+          </a:fillRef>
+          <a:effectRef idx="2">
+            <a:schemeClr val="accent1"/>
+          </a:effectRef>
+          <a:fontRef idx="minor">
+            <a:schemeClr val="lt1"/>
+          </a:fontRef>
+        </p:style>
+        <p:txBody>
+          <a:bodyPr rtlCol="0" anchor="ctr"/>
+          <a:lstStyle/>
+          <a:p>
+            <a:pPr algn="ctr"/>
+          </a:p>
+        </p:txBody>
+      </p:sp>
+      <p:sp>
+        <p:nvSpPr>
+          <p:cNvPr id="3" name="TextBox 2"/>
+          <p:cNvSpPr txBox="1"/>
+          <p:nvPr/>
+        </p:nvSpPr>
+        <p:spPr>
+          <a:xfrm>
+            <a:off x="731520" y="502920"/>
+            <a:ext cx="10698480" cy="320040"/>
+          </a:xfrm>
+          <a:prstGeom prst="rect">
+            <a:avLst/>
+          </a:prstGeom>
+          <a:noFill/>
+        </p:spPr>
+        <p:txBody>
+          <a:bodyPr wrap="square" anchor="t" lIns="0" rIns="0" tIns="0" bIns="0">
+            <a:spAutoFit/>
+          </a:bodyPr>
+          <a:lstStyle/>
+          <a:p>
+            <a:pPr algn="l">
+              <a:lnSpc>
+                <a:spcPct val="100000"/>
+              </a:lnSpc>
+              <a:spcAft>
+                <a:spcPts val="600"/>
+              </a:spcAft>
+            </a:pPr>
+            <a:r>
+              <a:rPr sz="1300" b="1" i="0">
+                <a:solidFill>
+                  <a:srgbClr val="C99B1C"/>
+                </a:solidFill>
+                <a:latin typeface="Calibri"/>
+              </a:rPr>
+              <a:t>WRAP-UP</a:t>
+            </a:r>
+          </a:p>
+        </p:txBody>
+      </p:sp>
+      <p:sp>
+        <p:nvSpPr>
+          <p:cNvPr id="4" name="TextBox 3"/>
+          <p:cNvSpPr txBox="1"/>
+          <p:nvPr/>
+        </p:nvSpPr>
+        <p:spPr>
+          <a:xfrm>
+            <a:off x="731520" y="868680"/>
+            <a:ext cx="10698480" cy="1280160"/>
+          </a:xfrm>
+          <a:prstGeom prst="rect">
+            <a:avLst/>
+          </a:prstGeom>
+          <a:noFill/>
+        </p:spPr>
+        <p:txBody>
+          <a:bodyPr wrap="square" anchor="t" lIns="0" rIns="0" tIns="0" bIns="0">
+            <a:spAutoFit/>
+          </a:bodyPr>
+          <a:lstStyle/>
+          <a:p>
+            <a:pPr algn="l">
+              <a:lnSpc>
+                <a:spcPct val="100000"/>
+              </a:lnSpc>
+              <a:spcAft>
+                <a:spcPts val="600"/>
+              </a:spcAft>
+            </a:pPr>
+            <a:r>
+              <a:rPr sz="3100" b="1" i="0">
+                <a:solidFill>
+                  <a:srgbClr val="FFFFFF"/>
+                </a:solidFill>
+                <a:latin typeface="Calibri"/>
+              </a:rPr>
+              <a:t>A Qualified Yes: ML Wins, but Narrowly, and Only the Trees</a:t>
+            </a:r>
+          </a:p>
+        </p:txBody>
+      </p:sp>
+      <p:sp>
+        <p:nvSpPr>
+          <p:cNvPr id="5" name="TextBox 4"/>
+          <p:cNvSpPr txBox="1"/>
+          <p:nvPr/>
+        </p:nvSpPr>
+        <p:spPr>
+          <a:xfrm>
+            <a:off x="731520" y="1965960"/>
+            <a:ext cx="10698480" cy="2651760"/>
+          </a:xfrm>
+          <a:prstGeom prst="rect">
+            <a:avLst/>
+          </a:prstGeom>
+          <a:noFill/>
+        </p:spPr>
+        <p:txBody>
+          <a:bodyPr wrap="square" anchor="t" lIns="0" rIns="0" tIns="0" bIns="0">
+            <a:spAutoFit/>
+          </a:bodyPr>
+          <a:lstStyle/>
+          <a:p>
+            <a:pPr algn="l">
+              <a:lnSpc>
                 <a:spcPct val="108000"/>
               </a:lnSpc>
               <a:spcAft>
@@ -5268,7 +6309,35 @@
                 </a:solidFill>
                 <a:latin typeface="Calibri"/>
               </a:rPr>
-              <a:t>the MLP loses to the scorecard outright, and the scorecard stays the better calibrated than either tree ensemble.</a:t>
+              <a:t>the MLP loses to the scorecard outright, and the scorecard stays better calibrated than either tree ensemble.</a:t>
+            </a:r>
+          </a:p>
+          <a:p>
+            <a:pPr algn="l">
+              <a:lnSpc>
+                <a:spcPct val="108000"/>
+              </a:lnSpc>
+              <a:spcAft>
+                <a:spcPts val="1300"/>
+              </a:spcAft>
+            </a:pPr>
+            <a:r>
+              <a:rPr sz="1550" b="1" i="0">
+                <a:solidFill>
+                  <a:srgbClr val="C99B1C"/>
+                </a:solidFill>
+                <a:latin typeface="Calibri"/>
+              </a:rPr>
+              <a:t>The margin depends on the information set:  </a:t>
+            </a:r>
+            <a:r>
+              <a:rPr sz="1550" b="0" i="0">
+                <a:solidFill>
+                  <a:srgbClr val="FFFFFF"/>
+                </a:solidFill>
+                <a:latin typeface="Calibri"/>
+              </a:rPr>
+              <a:t>withholding the platform's own pricing widens XGBoost's lead from 0.83 to 2.39 AUC points, so the headline number understates what ML offers a lender underwriting from bureau data directly.</a:t>
             </a:r>
           </a:p>
           <a:p>

</xml_diff>

<commit_message>
Describe the loan portfolio on the dataset slide
Adds a card summarising what the loans are (size, pricing, borrower
profile, purpose, housing, grade mix) in line with the report, plus the
FICO floor of 612 that explains the narrow score band. Existing bullets
condensed to make room; voiceover block extended to match.

Co-Authored-By: Claude Opus 4.8 <noreply@anthropic.com>
</commit_message>
<xml_diff>
--- a/report_and_video/Project_Video_Presentation.pptx
+++ b/report_and_video/Project_Video_Presentation.pptx
@@ -1004,7 +1004,7 @@
           <a:lstStyle/>
           <a:p>
             <a:r>
-              <a:t>Dataset: public Lending Club loans. Key decisions: 36-month loans so outcomes are fully observed; a strict origination-time whitelist against leakage; and an out-of-time vintage split rather than a random split. Robustness on the UCI Taiwan dataset.</a:t>
+              <a:t>Dataset: public Lending Club loans, and worth a moment on what they actually are. Small unsecured consumer loans, median ten thousand dollars over three years, mostly people refinancing more expensive credit-card debt. Note the FICO floor of 612: Lending Club had already screened everyone, which is why that field discriminates so weakly and why the achievable AUCs sit near 0.68. Then the two key decisions: the origination-time whitelist against leakage, and the out-of-time vintage split.</a:t>
             </a:r>
           </a:p>
         </p:txBody>
@@ -8092,7 +8092,7 @@
         </p:nvSpPr>
         <p:spPr>
           <a:xfrm>
-            <a:off x="457200" y="1645920"/>
+            <a:off x="457200" y="1481328"/>
             <a:ext cx="2743200" cy="822960"/>
           </a:xfrm>
           <a:prstGeom prst="rect">
@@ -8134,7 +8134,7 @@
         </p:nvSpPr>
         <p:spPr>
           <a:xfrm>
-            <a:off x="457200" y="2359152"/>
+            <a:off x="457200" y="2194560"/>
             <a:ext cx="2743200" cy="548640"/>
           </a:xfrm>
           <a:prstGeom prst="rect">
@@ -8176,7 +8176,7 @@
         </p:nvSpPr>
         <p:spPr>
           <a:xfrm>
-            <a:off x="3337560" y="1645920"/>
+            <a:off x="3337560" y="1481328"/>
             <a:ext cx="2743200" cy="822960"/>
           </a:xfrm>
           <a:prstGeom prst="rect">
@@ -8218,7 +8218,7 @@
         </p:nvSpPr>
         <p:spPr>
           <a:xfrm>
-            <a:off x="3337560" y="2359152"/>
+            <a:off x="3337560" y="2194560"/>
             <a:ext cx="2743200" cy="548640"/>
           </a:xfrm>
           <a:prstGeom prst="rect">
@@ -8260,7 +8260,7 @@
         </p:nvSpPr>
         <p:spPr>
           <a:xfrm>
-            <a:off x="6217920" y="1645920"/>
+            <a:off x="6217920" y="1481328"/>
             <a:ext cx="2743200" cy="822960"/>
           </a:xfrm>
           <a:prstGeom prst="rect">
@@ -8302,7 +8302,7 @@
         </p:nvSpPr>
         <p:spPr>
           <a:xfrm>
-            <a:off x="6217920" y="2359152"/>
+            <a:off x="6217920" y="2194560"/>
             <a:ext cx="2743200" cy="548640"/>
           </a:xfrm>
           <a:prstGeom prst="rect">
@@ -8344,7 +8344,7 @@
         </p:nvSpPr>
         <p:spPr>
           <a:xfrm>
-            <a:off x="9098280" y="1645920"/>
+            <a:off x="9098280" y="1481328"/>
             <a:ext cx="2743200" cy="822960"/>
           </a:xfrm>
           <a:prstGeom prst="rect">
@@ -8386,7 +8386,7 @@
         </p:nvSpPr>
         <p:spPr>
           <a:xfrm>
-            <a:off x="9098280" y="2359152"/>
+            <a:off x="9098280" y="2194560"/>
             <a:ext cx="2743200" cy="548640"/>
           </a:xfrm>
           <a:prstGeom prst="rect">
@@ -8422,14 +8422,60 @@
       </p:sp>
       <p:sp>
         <p:nvSpPr>
-          <p:cNvPr id="12" name="TextBox 11"/>
+          <p:cNvPr id="12" name="Rounded Rectangle 11"/>
+          <p:cNvSpPr/>
+          <p:nvPr/>
+        </p:nvSpPr>
+        <p:spPr>
+          <a:xfrm>
+            <a:off x="548640" y="2697480"/>
+            <a:ext cx="11064240" cy="1783080"/>
+          </a:xfrm>
+          <a:prstGeom prst="roundRect">
+            <a:avLst>
+              <a:gd name="adj" fmla="val 8000"/>
+            </a:avLst>
+          </a:prstGeom>
+          <a:solidFill>
+            <a:srgbClr val="EDF1F7"/>
+          </a:solidFill>
+          <a:ln>
+            <a:noFill/>
+          </a:ln>
+          <a:effectLst/>
+        </p:spPr>
+        <p:style>
+          <a:lnRef idx="1">
+            <a:schemeClr val="accent1"/>
+          </a:lnRef>
+          <a:fillRef idx="3">
+            <a:schemeClr val="accent1"/>
+          </a:fillRef>
+          <a:effectRef idx="2">
+            <a:schemeClr val="accent1"/>
+          </a:effectRef>
+          <a:fontRef idx="minor">
+            <a:schemeClr val="lt1"/>
+          </a:fontRef>
+        </p:style>
+        <p:txBody>
+          <a:bodyPr rtlCol="0" anchor="ctr"/>
+          <a:lstStyle/>
+          <a:p>
+            <a:pPr algn="ctr"/>
+          </a:p>
+        </p:txBody>
+      </p:sp>
+      <p:sp>
+        <p:nvSpPr>
+          <p:cNvPr id="13" name="TextBox 12"/>
           <p:cNvSpPr txBox="1"/>
           <p:nvPr/>
         </p:nvSpPr>
         <p:spPr>
           <a:xfrm>
-            <a:off x="548640" y="3291840"/>
-            <a:ext cx="10972800" cy="3017520"/>
+            <a:off x="868680" y="2852928"/>
+            <a:ext cx="3657600" cy="320040"/>
           </a:xfrm>
           <a:prstGeom prst="rect">
             <a:avLst/>
@@ -8444,6 +8490,603 @@
           <a:p>
             <a:pPr algn="l">
               <a:lnSpc>
+                <a:spcPct val="100000"/>
+              </a:lnSpc>
+              <a:spcAft>
+                <a:spcPts val="600"/>
+              </a:spcAft>
+            </a:pPr>
+            <a:r>
+              <a:rPr sz="1550" b="1" i="0">
+                <a:solidFill>
+                  <a:srgbClr val="1B3A6B"/>
+                </a:solidFill>
+                <a:latin typeface="Calibri"/>
+              </a:rPr>
+              <a:t>Small unsecured consumer loans</a:t>
+            </a:r>
+          </a:p>
+        </p:txBody>
+      </p:sp>
+      <p:sp>
+        <p:nvSpPr>
+          <p:cNvPr id="14" name="TextBox 13"/>
+          <p:cNvSpPr txBox="1"/>
+          <p:nvPr/>
+        </p:nvSpPr>
+        <p:spPr>
+          <a:xfrm>
+            <a:off x="868680" y="3246120"/>
+            <a:ext cx="1005840" cy="320040"/>
+          </a:xfrm>
+          <a:prstGeom prst="rect">
+            <a:avLst/>
+          </a:prstGeom>
+          <a:noFill/>
+        </p:spPr>
+        <p:txBody>
+          <a:bodyPr wrap="square" anchor="t" lIns="0" rIns="0" tIns="0" bIns="0">
+            <a:spAutoFit/>
+          </a:bodyPr>
+          <a:lstStyle/>
+          <a:p>
+            <a:pPr algn="l">
+              <a:lnSpc>
+                <a:spcPct val="100000"/>
+              </a:lnSpc>
+              <a:spcAft>
+                <a:spcPts val="600"/>
+              </a:spcAft>
+            </a:pPr>
+            <a:r>
+              <a:rPr sz="1250" b="1" i="0">
+                <a:solidFill>
+                  <a:srgbClr val="C99B1C"/>
+                </a:solidFill>
+                <a:latin typeface="Calibri"/>
+              </a:rPr>
+              <a:t>Size</a:t>
+            </a:r>
+          </a:p>
+        </p:txBody>
+      </p:sp>
+      <p:sp>
+        <p:nvSpPr>
+          <p:cNvPr id="15" name="TextBox 14"/>
+          <p:cNvSpPr txBox="1"/>
+          <p:nvPr/>
+        </p:nvSpPr>
+        <p:spPr>
+          <a:xfrm>
+            <a:off x="1920240" y="3246120"/>
+            <a:ext cx="4023360" cy="320040"/>
+          </a:xfrm>
+          <a:prstGeom prst="rect">
+            <a:avLst/>
+          </a:prstGeom>
+          <a:noFill/>
+        </p:spPr>
+        <p:txBody>
+          <a:bodyPr wrap="square" anchor="t" lIns="0" rIns="0" tIns="0" bIns="0">
+            <a:spAutoFit/>
+          </a:bodyPr>
+          <a:lstStyle/>
+          <a:p>
+            <a:pPr algn="l">
+              <a:lnSpc>
+                <a:spcPct val="100000"/>
+              </a:lnSpc>
+              <a:spcAft>
+                <a:spcPts val="600"/>
+              </a:spcAft>
+            </a:pPr>
+            <a:r>
+              <a:rPr sz="1250" b="0" i="0">
+                <a:solidFill>
+                  <a:srgbClr val="212121"/>
+                </a:solidFill>
+                <a:latin typeface="Calibri"/>
+              </a:rPr>
+              <a:t>$500 to the $35,000 ceiling, median $10,000, $342 a month</a:t>
+            </a:r>
+          </a:p>
+        </p:txBody>
+      </p:sp>
+      <p:sp>
+        <p:nvSpPr>
+          <p:cNvPr id="16" name="TextBox 15"/>
+          <p:cNvSpPr txBox="1"/>
+          <p:nvPr/>
+        </p:nvSpPr>
+        <p:spPr>
+          <a:xfrm>
+            <a:off x="868680" y="3611880"/>
+            <a:ext cx="1005840" cy="320040"/>
+          </a:xfrm>
+          <a:prstGeom prst="rect">
+            <a:avLst/>
+          </a:prstGeom>
+          <a:noFill/>
+        </p:spPr>
+        <p:txBody>
+          <a:bodyPr wrap="square" anchor="t" lIns="0" rIns="0" tIns="0" bIns="0">
+            <a:spAutoFit/>
+          </a:bodyPr>
+          <a:lstStyle/>
+          <a:p>
+            <a:pPr algn="l">
+              <a:lnSpc>
+                <a:spcPct val="100000"/>
+              </a:lnSpc>
+              <a:spcAft>
+                <a:spcPts val="600"/>
+              </a:spcAft>
+            </a:pPr>
+            <a:r>
+              <a:rPr sz="1250" b="1" i="0">
+                <a:solidFill>
+                  <a:srgbClr val="C99B1C"/>
+                </a:solidFill>
+                <a:latin typeface="Calibri"/>
+              </a:rPr>
+              <a:t>Price</a:t>
+            </a:r>
+          </a:p>
+        </p:txBody>
+      </p:sp>
+      <p:sp>
+        <p:nvSpPr>
+          <p:cNvPr id="17" name="TextBox 16"/>
+          <p:cNvSpPr txBox="1"/>
+          <p:nvPr/>
+        </p:nvSpPr>
+        <p:spPr>
+          <a:xfrm>
+            <a:off x="1920240" y="3611880"/>
+            <a:ext cx="4023360" cy="320040"/>
+          </a:xfrm>
+          <a:prstGeom prst="rect">
+            <a:avLst/>
+          </a:prstGeom>
+          <a:noFill/>
+        </p:spPr>
+        <p:txBody>
+          <a:bodyPr wrap="square" anchor="t" lIns="0" rIns="0" tIns="0" bIns="0">
+            <a:spAutoFit/>
+          </a:bodyPr>
+          <a:lstStyle/>
+          <a:p>
+            <a:pPr algn="l">
+              <a:lnSpc>
+                <a:spcPct val="100000"/>
+              </a:lnSpc>
+              <a:spcAft>
+                <a:spcPts val="600"/>
+              </a:spcAft>
+            </a:pPr>
+            <a:r>
+              <a:rPr sz="1250" b="0" i="0">
+                <a:solidFill>
+                  <a:srgbClr val="212121"/>
+                </a:solidFill>
+                <a:latin typeface="Calibri"/>
+              </a:rPr>
+              <a:t>5.3% to 29.0%, mean near 12%</a:t>
+            </a:r>
+          </a:p>
+        </p:txBody>
+      </p:sp>
+      <p:sp>
+        <p:nvSpPr>
+          <p:cNvPr id="18" name="TextBox 17"/>
+          <p:cNvSpPr txBox="1"/>
+          <p:nvPr/>
+        </p:nvSpPr>
+        <p:spPr>
+          <a:xfrm>
+            <a:off x="868680" y="3977640"/>
+            <a:ext cx="1005840" cy="320040"/>
+          </a:xfrm>
+          <a:prstGeom prst="rect">
+            <a:avLst/>
+          </a:prstGeom>
+          <a:noFill/>
+        </p:spPr>
+        <p:txBody>
+          <a:bodyPr wrap="square" anchor="t" lIns="0" rIns="0" tIns="0" bIns="0">
+            <a:spAutoFit/>
+          </a:bodyPr>
+          <a:lstStyle/>
+          <a:p>
+            <a:pPr algn="l">
+              <a:lnSpc>
+                <a:spcPct val="100000"/>
+              </a:lnSpc>
+              <a:spcAft>
+                <a:spcPts val="600"/>
+              </a:spcAft>
+            </a:pPr>
+            <a:r>
+              <a:rPr sz="1250" b="1" i="0">
+                <a:solidFill>
+                  <a:srgbClr val="C99B1C"/>
+                </a:solidFill>
+                <a:latin typeface="Calibri"/>
+              </a:rPr>
+              <a:t>Borrower</a:t>
+            </a:r>
+          </a:p>
+        </p:txBody>
+      </p:sp>
+      <p:sp>
+        <p:nvSpPr>
+          <p:cNvPr id="19" name="TextBox 18"/>
+          <p:cNvSpPr txBox="1"/>
+          <p:nvPr/>
+        </p:nvSpPr>
+        <p:spPr>
+          <a:xfrm>
+            <a:off x="1920240" y="3977640"/>
+            <a:ext cx="4023360" cy="320040"/>
+          </a:xfrm>
+          <a:prstGeom prst="rect">
+            <a:avLst/>
+          </a:prstGeom>
+          <a:noFill/>
+        </p:spPr>
+        <p:txBody>
+          <a:bodyPr wrap="square" anchor="t" lIns="0" rIns="0" tIns="0" bIns="0">
+            <a:spAutoFit/>
+          </a:bodyPr>
+          <a:lstStyle/>
+          <a:p>
+            <a:pPr algn="l">
+              <a:lnSpc>
+                <a:spcPct val="100000"/>
+              </a:lnSpc>
+              <a:spcAft>
+                <a:spcPts val="600"/>
+              </a:spcAft>
+            </a:pPr>
+            <a:r>
+              <a:rPr sz="1250" b="0" i="0">
+                <a:solidFill>
+                  <a:srgbClr val="212121"/>
+                </a:solidFill>
+                <a:latin typeface="Calibri"/>
+              </a:rPr>
+              <a:t>median income $60,000, DTI 17%, 15 years of credit history</a:t>
+            </a:r>
+          </a:p>
+        </p:txBody>
+      </p:sp>
+      <p:sp>
+        <p:nvSpPr>
+          <p:cNvPr id="20" name="TextBox 19"/>
+          <p:cNvSpPr txBox="1"/>
+          <p:nvPr/>
+        </p:nvSpPr>
+        <p:spPr>
+          <a:xfrm>
+            <a:off x="6309360" y="3246120"/>
+            <a:ext cx="1005840" cy="320040"/>
+          </a:xfrm>
+          <a:prstGeom prst="rect">
+            <a:avLst/>
+          </a:prstGeom>
+          <a:noFill/>
+        </p:spPr>
+        <p:txBody>
+          <a:bodyPr wrap="square" anchor="t" lIns="0" rIns="0" tIns="0" bIns="0">
+            <a:spAutoFit/>
+          </a:bodyPr>
+          <a:lstStyle/>
+          <a:p>
+            <a:pPr algn="l">
+              <a:lnSpc>
+                <a:spcPct val="100000"/>
+              </a:lnSpc>
+              <a:spcAft>
+                <a:spcPts val="600"/>
+              </a:spcAft>
+            </a:pPr>
+            <a:r>
+              <a:rPr sz="1250" b="1" i="0">
+                <a:solidFill>
+                  <a:srgbClr val="C99B1C"/>
+                </a:solidFill>
+                <a:latin typeface="Calibri"/>
+              </a:rPr>
+              <a:t>Purpose</a:t>
+            </a:r>
+          </a:p>
+        </p:txBody>
+      </p:sp>
+      <p:sp>
+        <p:nvSpPr>
+          <p:cNvPr id="21" name="TextBox 20"/>
+          <p:cNvSpPr txBox="1"/>
+          <p:nvPr/>
+        </p:nvSpPr>
+        <p:spPr>
+          <a:xfrm>
+            <a:off x="7360920" y="3246120"/>
+            <a:ext cx="4023360" cy="320040"/>
+          </a:xfrm>
+          <a:prstGeom prst="rect">
+            <a:avLst/>
+          </a:prstGeom>
+          <a:noFill/>
+        </p:spPr>
+        <p:txBody>
+          <a:bodyPr wrap="square" anchor="t" lIns="0" rIns="0" tIns="0" bIns="0">
+            <a:spAutoFit/>
+          </a:bodyPr>
+          <a:lstStyle/>
+          <a:p>
+            <a:pPr algn="l">
+              <a:lnSpc>
+                <a:spcPct val="100000"/>
+              </a:lnSpc>
+              <a:spcAft>
+                <a:spcPts val="600"/>
+              </a:spcAft>
+            </a:pPr>
+            <a:r>
+              <a:rPr sz="1250" b="0" i="0">
+                <a:solidFill>
+                  <a:srgbClr val="212121"/>
+                </a:solidFill>
+                <a:latin typeface="Calibri"/>
+              </a:rPr>
+              <a:t>57% debt consolidation, 24% credit card: refinancing</a:t>
+            </a:r>
+          </a:p>
+        </p:txBody>
+      </p:sp>
+      <p:sp>
+        <p:nvSpPr>
+          <p:cNvPr id="22" name="TextBox 21"/>
+          <p:cNvSpPr txBox="1"/>
+          <p:nvPr/>
+        </p:nvSpPr>
+        <p:spPr>
+          <a:xfrm>
+            <a:off x="6309360" y="3611880"/>
+            <a:ext cx="1005840" cy="320040"/>
+          </a:xfrm>
+          <a:prstGeom prst="rect">
+            <a:avLst/>
+          </a:prstGeom>
+          <a:noFill/>
+        </p:spPr>
+        <p:txBody>
+          <a:bodyPr wrap="square" anchor="t" lIns="0" rIns="0" tIns="0" bIns="0">
+            <a:spAutoFit/>
+          </a:bodyPr>
+          <a:lstStyle/>
+          <a:p>
+            <a:pPr algn="l">
+              <a:lnSpc>
+                <a:spcPct val="100000"/>
+              </a:lnSpc>
+              <a:spcAft>
+                <a:spcPts val="600"/>
+              </a:spcAft>
+            </a:pPr>
+            <a:r>
+              <a:rPr sz="1250" b="1" i="0">
+                <a:solidFill>
+                  <a:srgbClr val="C99B1C"/>
+                </a:solidFill>
+                <a:latin typeface="Calibri"/>
+              </a:rPr>
+              <a:t>Housing</a:t>
+            </a:r>
+          </a:p>
+        </p:txBody>
+      </p:sp>
+      <p:sp>
+        <p:nvSpPr>
+          <p:cNvPr id="23" name="TextBox 22"/>
+          <p:cNvSpPr txBox="1"/>
+          <p:nvPr/>
+        </p:nvSpPr>
+        <p:spPr>
+          <a:xfrm>
+            <a:off x="7360920" y="3611880"/>
+            <a:ext cx="4023360" cy="320040"/>
+          </a:xfrm>
+          <a:prstGeom prst="rect">
+            <a:avLst/>
+          </a:prstGeom>
+          <a:noFill/>
+        </p:spPr>
+        <p:txBody>
+          <a:bodyPr wrap="square" anchor="t" lIns="0" rIns="0" tIns="0" bIns="0">
+            <a:spAutoFit/>
+          </a:bodyPr>
+          <a:lstStyle/>
+          <a:p>
+            <a:pPr algn="l">
+              <a:lnSpc>
+                <a:spcPct val="100000"/>
+              </a:lnSpc>
+              <a:spcAft>
+                <a:spcPts val="600"/>
+              </a:spcAft>
+            </a:pPr>
+            <a:r>
+              <a:rPr sz="1250" b="0" i="0">
+                <a:solidFill>
+                  <a:srgbClr val="212121"/>
+                </a:solidFill>
+                <a:latin typeface="Calibri"/>
+              </a:rPr>
+              <a:t>46% mortgage, 43% renting, 10% owned</a:t>
+            </a:r>
+          </a:p>
+        </p:txBody>
+      </p:sp>
+      <p:sp>
+        <p:nvSpPr>
+          <p:cNvPr id="24" name="TextBox 23"/>
+          <p:cNvSpPr txBox="1"/>
+          <p:nvPr/>
+        </p:nvSpPr>
+        <p:spPr>
+          <a:xfrm>
+            <a:off x="6309360" y="3977640"/>
+            <a:ext cx="1005840" cy="320040"/>
+          </a:xfrm>
+          <a:prstGeom prst="rect">
+            <a:avLst/>
+          </a:prstGeom>
+          <a:noFill/>
+        </p:spPr>
+        <p:txBody>
+          <a:bodyPr wrap="square" anchor="t" lIns="0" rIns="0" tIns="0" bIns="0">
+            <a:spAutoFit/>
+          </a:bodyPr>
+          <a:lstStyle/>
+          <a:p>
+            <a:pPr algn="l">
+              <a:lnSpc>
+                <a:spcPct val="100000"/>
+              </a:lnSpc>
+              <a:spcAft>
+                <a:spcPts val="600"/>
+              </a:spcAft>
+            </a:pPr>
+            <a:r>
+              <a:rPr sz="1250" b="1" i="0">
+                <a:solidFill>
+                  <a:srgbClr val="C99B1C"/>
+                </a:solidFill>
+                <a:latin typeface="Calibri"/>
+              </a:rPr>
+              <a:t>Grades</a:t>
+            </a:r>
+          </a:p>
+        </p:txBody>
+      </p:sp>
+      <p:sp>
+        <p:nvSpPr>
+          <p:cNvPr id="25" name="TextBox 24"/>
+          <p:cNvSpPr txBox="1"/>
+          <p:nvPr/>
+        </p:nvSpPr>
+        <p:spPr>
+          <a:xfrm>
+            <a:off x="7360920" y="3977640"/>
+            <a:ext cx="4023360" cy="320040"/>
+          </a:xfrm>
+          <a:prstGeom prst="rect">
+            <a:avLst/>
+          </a:prstGeom>
+          <a:noFill/>
+        </p:spPr>
+        <p:txBody>
+          <a:bodyPr wrap="square" anchor="t" lIns="0" rIns="0" tIns="0" bIns="0">
+            <a:spAutoFit/>
+          </a:bodyPr>
+          <a:lstStyle/>
+          <a:p>
+            <a:pPr algn="l">
+              <a:lnSpc>
+                <a:spcPct val="100000"/>
+              </a:lnSpc>
+              <a:spcAft>
+                <a:spcPts val="600"/>
+              </a:spcAft>
+            </a:pPr>
+            <a:r>
+              <a:rPr sz="1250" b="0" i="0">
+                <a:solidFill>
+                  <a:srgbClr val="212121"/>
+                </a:solidFill>
+                <a:latin typeface="Calibri"/>
+              </a:rPr>
+              <a:t>A to D is 96% of the book; E to G only 4.3%</a:t>
+            </a:r>
+          </a:p>
+        </p:txBody>
+      </p:sp>
+      <p:sp>
+        <p:nvSpPr>
+          <p:cNvPr id="26" name="TextBox 25"/>
+          <p:cNvSpPr txBox="1"/>
+          <p:nvPr/>
+        </p:nvSpPr>
+        <p:spPr>
+          <a:xfrm>
+            <a:off x="6309360" y="2852928"/>
+            <a:ext cx="5120640" cy="320040"/>
+          </a:xfrm>
+          <a:prstGeom prst="rect">
+            <a:avLst/>
+          </a:prstGeom>
+          <a:noFill/>
+        </p:spPr>
+        <p:txBody>
+          <a:bodyPr wrap="square" anchor="t" lIns="0" rIns="0" tIns="0" bIns="0">
+            <a:spAutoFit/>
+          </a:bodyPr>
+          <a:lstStyle/>
+          <a:p>
+            <a:pPr algn="l">
+              <a:lnSpc>
+                <a:spcPct val="100000"/>
+              </a:lnSpc>
+              <a:spcAft>
+                <a:spcPts val="600"/>
+              </a:spcAft>
+            </a:pPr>
+            <a:r>
+              <a:rPr sz="1250" b="1" i="0">
+                <a:solidFill>
+                  <a:srgbClr val="1B3A6B"/>
+                </a:solidFill>
+                <a:latin typeface="Calibri"/>
+              </a:rPr>
+              <a:t>FICO floor 612, median 692:  </a:t>
+            </a:r>
+            <a:r>
+              <a:rPr sz="1250" b="0" i="0">
+                <a:solidFill>
+                  <a:srgbClr val="212121"/>
+                </a:solidFill>
+                <a:latin typeface="Calibri"/>
+              </a:rPr>
+              <a:t>a narrow band, by design</a:t>
+            </a:r>
+          </a:p>
+        </p:txBody>
+      </p:sp>
+      <p:sp>
+        <p:nvSpPr>
+          <p:cNvPr id="27" name="TextBox 26"/>
+          <p:cNvSpPr txBox="1"/>
+          <p:nvPr/>
+        </p:nvSpPr>
+        <p:spPr>
+          <a:xfrm>
+            <a:off x="548640" y="4709160"/>
+            <a:ext cx="11064240" cy="1920240"/>
+          </a:xfrm>
+          <a:prstGeom prst="rect">
+            <a:avLst/>
+          </a:prstGeom>
+          <a:noFill/>
+        </p:spPr>
+        <p:txBody>
+          <a:bodyPr wrap="square" anchor="t" lIns="0" rIns="0" tIns="0" bIns="0">
+            <a:spAutoFit/>
+          </a:bodyPr>
+          <a:lstStyle/>
+          <a:p>
+            <a:pPr algn="l">
+              <a:lnSpc>
                 <a:spcPct val="105000"/>
               </a:lnSpc>
               <a:spcAft>
@@ -8451,22 +9094,22 @@
               </a:spcAft>
             </a:pPr>
             <a:r>
-              <a:rPr sz="1500" b="1" i="0">
+              <a:rPr sz="1450" b="1" i="0">
                 <a:solidFill>
                   <a:srgbClr val="1B3A6B"/>
                 </a:solidFill>
                 <a:latin typeface="Calibri"/>
               </a:rPr>
-              <a:t>Source:  </a:t>
-            </a:r>
-            <a:r>
-              <a:rPr sz="1500" b="0" i="0">
+              <a:t>The leakage filter is the hard work:  </a:t>
+            </a:r>
+            <a:r>
+              <a:rPr sz="1450" b="0" i="0">
                 <a:solidFill>
                   <a:srgbClr val="212121"/>
                 </a:solidFill>
                 <a:latin typeface="Calibri"/>
               </a:rPr>
-              <a:t>public Lending Club export (Kaggle); 36-month loans only, so every loan matures before the data ends and no outcome is censored.</a:t>
+              <a:t>of the 151 raw columns, most are post-origination servicing fields (payments received, recoveries, hardship flags) that trivially predict the outcome. I kept an explicit whitelist of 23 origination-time fields.</a:t>
             </a:r>
           </a:p>
           <a:p>
@@ -8479,78 +9122,22 @@
               </a:spcAft>
             </a:pPr>
             <a:r>
-              <a:rPr sz="1500" b="1" i="0">
+              <a:rPr sz="1450" b="1" i="0">
                 <a:solidFill>
                   <a:srgbClr val="1B3A6B"/>
                 </a:solidFill>
                 <a:latin typeface="Calibri"/>
               </a:rPr>
-              <a:t>Target:  </a:t>
-            </a:r>
-            <a:r>
-              <a:rPr sz="1500" b="0" i="0">
+              <a:t>Out-of-time split:  </a:t>
+            </a:r>
+            <a:r>
+              <a:rPr sz="1450" b="0" i="0">
                 <a:solidFill>
                   <a:srgbClr val="212121"/>
                 </a:solidFill>
                 <a:latin typeface="Calibri"/>
               </a:rPr>
-              <a:t>charged-off vs fully paid; loans still in flight are excluded.</a:t>
-            </a:r>
-          </a:p>
-          <a:p>
-            <a:pPr algn="l">
-              <a:lnSpc>
-                <a:spcPct val="105000"/>
-              </a:lnSpc>
-              <a:spcAft>
-                <a:spcPts val="900"/>
-              </a:spcAft>
-            </a:pPr>
-            <a:r>
-              <a:rPr sz="1500" b="1" i="0">
-                <a:solidFill>
-                  <a:srgbClr val="1B3A6B"/>
-                </a:solidFill>
-                <a:latin typeface="Calibri"/>
-              </a:rPr>
-              <a:t>The leakage filter is the hard work:  </a:t>
-            </a:r>
-            <a:r>
-              <a:rPr sz="1500" b="0" i="0">
-                <a:solidFill>
-                  <a:srgbClr val="212121"/>
-                </a:solidFill>
-                <a:latin typeface="Calibri"/>
-              </a:rPr>
-              <a:t>the raw export has 151 columns, most of them post-origination servicing fields (payments received, recoveries, hardship flags) that trivially predict the outcome. I kept an explicit whitelist of 23 origination-time fields.</a:t>
-            </a:r>
-          </a:p>
-          <a:p>
-            <a:pPr algn="l">
-              <a:lnSpc>
-                <a:spcPct val="105000"/>
-              </a:lnSpc>
-              <a:spcAft>
-                <a:spcPts val="900"/>
-              </a:spcAft>
-            </a:pPr>
-            <a:r>
-              <a:rPr sz="1500" b="1" i="0">
-                <a:solidFill>
-                  <a:srgbClr val="1B3A6B"/>
-                </a:solidFill>
-                <a:latin typeface="Calibri"/>
-              </a:rPr>
-              <a:t>Out-of-time split:  </a:t>
-            </a:r>
-            <a:r>
-              <a:rPr sz="1500" b="0" i="0">
-                <a:solidFill>
-                  <a:srgbClr val="212121"/>
-                </a:solidFill>
-                <a:latin typeface="Calibri"/>
-              </a:rPr>
-              <a:t>train on 2007-2013 vintages, calibrate on 2014, test on 2015, exactly how a deployed model meets the future. The rising default rate across vintages is the drift a real model faces.</a:t>
+              <a:t>train on 2007-2013, calibrate on 2014, test on 2015, exactly how a deployed model meets the future. The rising default rate across vintages is the drift a real model faces.</a:t>
             </a:r>
           </a:p>
         </p:txBody>

</xml_diff>

<commit_message>
Show kept vs discarded features on the approach slide
Adds two panels naming the origination-time fields retained and the
post-origination columns dropped, with total_rec_prncp called out as
the clearest case: it equals the loan amount for every repaid loan.
Package listing and design bullets condensed to make room; voiceover
block extended to match.

Co-Authored-By: Claude Opus 4.8 <noreply@anthropic.com>
</commit_message>
<xml_diff>
--- a/report_and_video/Project_Video_Presentation.pptx
+++ b/report_and_video/Project_Video_Presentation.pptx
@@ -1074,7 +1074,7 @@
           <a:lstStyle/>
           <a:p>
             <a:r>
-              <a:t>Walk through the package structure on screen here. Emphasize: honest WoE scorecard baseline, shared design matrix, calibration fit only on the validation vintage, profit from actual loan cash flows.</a:t>
+              <a:t>Walk through the package on screen here. The design principles: an honest scorecard baseline, identical information for all four models, calibration separated from fitting, and profit from real cash flows. Then the concrete version of the leakage decision: on the left what I kept, all knowable on the day of application; on the right what I threw away. Point at total_rec_prncp: principal received to date equals the loan amount for every repaid loan, so a model using it scores near-perfectly and has learned nothing.</a:t>
             </a:r>
           </a:p>
         </p:txBody>
@@ -9252,8 +9252,8 @@
         </p:nvSpPr>
         <p:spPr>
           <a:xfrm>
-            <a:off x="548640" y="1645920"/>
-            <a:ext cx="5577840" cy="4206240"/>
+            <a:off x="548640" y="1554480"/>
+            <a:ext cx="5394960" cy="2697480"/>
           </a:xfrm>
           <a:prstGeom prst="roundRect">
             <a:avLst>
@@ -9298,8 +9298,8 @@
         </p:nvSpPr>
         <p:spPr>
           <a:xfrm>
-            <a:off x="822960" y="1828800"/>
-            <a:ext cx="5029200" cy="365760"/>
+            <a:off x="822960" y="1691640"/>
+            <a:ext cx="4846320" cy="320040"/>
           </a:xfrm>
           <a:prstGeom prst="rect">
             <a:avLst/>
@@ -9321,7 +9321,7 @@
               </a:spcAft>
             </a:pPr>
             <a:r>
-              <a:rPr sz="1700" b="1" i="0">
+              <a:rPr sz="1550" b="1" i="0">
                 <a:solidFill>
                   <a:srgbClr val="1B3A6B"/>
                 </a:solidFill>
@@ -9340,8 +9340,8 @@
         </p:nvSpPr>
         <p:spPr>
           <a:xfrm>
-            <a:off x="822960" y="2286000"/>
-            <a:ext cx="5029200" cy="3474720"/>
+            <a:off x="822960" y="2084831"/>
+            <a:ext cx="4846320" cy="2103120"/>
           </a:xfrm>
           <a:prstGeom prst="rect">
             <a:avLst/>
@@ -9359,11 +9359,11 @@
                 <a:spcPct val="100000"/>
               </a:lnSpc>
               <a:spcAft>
-                <a:spcPts val="900"/>
-              </a:spcAft>
-            </a:pPr>
-            <a:r>
-              <a:rPr sz="1450" b="1" i="0">
+                <a:spcPts val="500"/>
+              </a:spcAft>
+            </a:pPr>
+            <a:r>
+              <a:rPr sz="1250" b="1" i="0">
                 <a:solidFill>
                   <a:srgbClr val="C99B1C"/>
                 </a:solidFill>
@@ -9372,13 +9372,13 @@
               <a:t>data</a:t>
             </a:r>
             <a:r>
-              <a:rPr sz="1450" b="0" i="0">
+              <a:rPr sz="1250" b="0" i="0">
                 <a:solidFill>
                   <a:srgbClr val="212121"/>
                 </a:solidFill>
                 <a:latin typeface="Calibri"/>
               </a:rPr>
-              <a:t>  loaders + leakage whitelist + vintage split</a:t>
+              <a:t>  whitelist + vintage split</a:t>
             </a:r>
           </a:p>
           <a:p>
@@ -9387,11 +9387,11 @@
                 <a:spcPct val="100000"/>
               </a:lnSpc>
               <a:spcAft>
-                <a:spcPts val="900"/>
-              </a:spcAft>
-            </a:pPr>
-            <a:r>
-              <a:rPr sz="1450" b="1" i="0">
+                <a:spcPts val="500"/>
+              </a:spcAft>
+            </a:pPr>
+            <a:r>
+              <a:rPr sz="1250" b="1" i="0">
                 <a:solidFill>
                   <a:srgbClr val="C99B1C"/>
                 </a:solidFill>
@@ -9400,13 +9400,13 @@
               <a:t>woe / scorecard</a:t>
             </a:r>
             <a:r>
-              <a:rPr sz="1450" b="0" i="0">
+              <a:rPr sz="1250" b="0" i="0">
                 <a:solidFill>
                   <a:srgbClr val="212121"/>
                 </a:solidFill>
                 <a:latin typeface="Calibri"/>
               </a:rPr>
-              <a:t>  WoE binning, IV screen, logistic, points scaling</a:t>
+              <a:t>  binning, IV screen, points</a:t>
             </a:r>
           </a:p>
           <a:p>
@@ -9415,11 +9415,11 @@
                 <a:spcPct val="100000"/>
               </a:lnSpc>
               <a:spcAft>
-                <a:spcPts val="900"/>
-              </a:spcAft>
-            </a:pPr>
-            <a:r>
-              <a:rPr sz="1450" b="1" i="0">
+                <a:spcPts val="500"/>
+              </a:spcAft>
+            </a:pPr>
+            <a:r>
+              <a:rPr sz="1250" b="1" i="0">
                 <a:solidFill>
                   <a:srgbClr val="C99B1C"/>
                 </a:solidFill>
@@ -9428,13 +9428,13 @@
               <a:t>models</a:t>
             </a:r>
             <a:r>
-              <a:rPr sz="1450" b="0" i="0">
+              <a:rPr sz="1250" b="0" i="0">
                 <a:solidFill>
                   <a:srgbClr val="212121"/>
                 </a:solidFill>
                 <a:latin typeface="Calibri"/>
               </a:rPr>
-              <a:t>  XGBoost, LightGBM, MLP on a shared design matrix</a:t>
+              <a:t>  XGBoost, LightGBM, MLP</a:t>
             </a:r>
           </a:p>
           <a:p>
@@ -9443,11 +9443,11 @@
                 <a:spcPct val="100000"/>
               </a:lnSpc>
               <a:spcAft>
-                <a:spcPts val="900"/>
-              </a:spcAft>
-            </a:pPr>
-            <a:r>
-              <a:rPr sz="1450" b="1" i="0">
+                <a:spcPts val="500"/>
+              </a:spcAft>
+            </a:pPr>
+            <a:r>
+              <a:rPr sz="1250" b="1" i="0">
                 <a:solidFill>
                   <a:srgbClr val="C99B1C"/>
                 </a:solidFill>
@@ -9456,13 +9456,13 @@
               <a:t>calibration</a:t>
             </a:r>
             <a:r>
-              <a:rPr sz="1450" b="0" i="0">
+              <a:rPr sz="1250" b="0" i="0">
                 <a:solidFill>
                   <a:srgbClr val="212121"/>
                 </a:solidFill>
                 <a:latin typeface="Calibri"/>
               </a:rPr>
-              <a:t>  Platt + isotonic, fit on the 2014 vintage</a:t>
+              <a:t>  Platt + isotonic on 2014</a:t>
             </a:r>
           </a:p>
           <a:p>
@@ -9471,11 +9471,11 @@
                 <a:spcPct val="100000"/>
               </a:lnSpc>
               <a:spcAft>
-                <a:spcPts val="900"/>
-              </a:spcAft>
-            </a:pPr>
-            <a:r>
-              <a:rPr sz="1450" b="1" i="0">
+                <a:spcPts val="500"/>
+              </a:spcAft>
+            </a:pPr>
+            <a:r>
+              <a:rPr sz="1250" b="1" i="0">
                 <a:solidFill>
                   <a:srgbClr val="C99B1C"/>
                 </a:solidFill>
@@ -9484,13 +9484,13 @@
               <a:t>metrics</a:t>
             </a:r>
             <a:r>
-              <a:rPr sz="1450" b="0" i="0">
+              <a:rPr sz="1250" b="0" i="0">
                 <a:solidFill>
                   <a:srgbClr val="212121"/>
                 </a:solidFill>
                 <a:latin typeface="Calibri"/>
               </a:rPr>
-              <a:t>  AUC, KS, Brier, ECE, DeLong test, bootstrap CIs</a:t>
+              <a:t>  AUC, KS, Brier, ECE, DeLong</a:t>
             </a:r>
           </a:p>
           <a:p>
@@ -9499,11 +9499,11 @@
                 <a:spcPct val="100000"/>
               </a:lnSpc>
               <a:spcAft>
-                <a:spcPts val="900"/>
-              </a:spcAft>
-            </a:pPr>
-            <a:r>
-              <a:rPr sz="1450" b="1" i="0">
+                <a:spcPts val="500"/>
+              </a:spcAft>
+            </a:pPr>
+            <a:r>
+              <a:rPr sz="1250" b="1" i="0">
                 <a:solidFill>
                   <a:srgbClr val="C99B1C"/>
                 </a:solidFill>
@@ -9512,13 +9512,13 @@
               <a:t>decision</a:t>
             </a:r>
             <a:r>
-              <a:rPr sz="1450" b="0" i="0">
+              <a:rPr sz="1250" b="0" i="0">
                 <a:solidFill>
                   <a:srgbClr val="212121"/>
                 </a:solidFill>
                 <a:latin typeface="Calibri"/>
               </a:rPr>
-              <a:t>  accept/reject profit sweep over PD cutoffs</a:t>
+              <a:t>  profit sweep over cutoffs</a:t>
             </a:r>
           </a:p>
           <a:p>
@@ -9527,11 +9527,11 @@
                 <a:spcPct val="100000"/>
               </a:lnSpc>
               <a:spcAft>
-                <a:spcPts val="900"/>
-              </a:spcAft>
-            </a:pPr>
-            <a:r>
-              <a:rPr sz="1450" b="1" i="0">
+                <a:spcPts val="500"/>
+              </a:spcAft>
+            </a:pPr>
+            <a:r>
+              <a:rPr sz="1250" b="1" i="0">
                 <a:solidFill>
                   <a:srgbClr val="C99B1C"/>
                 </a:solidFill>
@@ -9540,13 +9540,13 @@
               <a:t>pipeline</a:t>
             </a:r>
             <a:r>
-              <a:rPr sz="1450" b="0" i="0">
+              <a:rPr sz="1250" b="0" i="0">
                 <a:solidFill>
                   <a:srgbClr val="212121"/>
                 </a:solidFill>
                 <a:latin typeface="Calibri"/>
               </a:rPr>
-              <a:t>  end-to-end orchestration, 5 seeds per ML model</a:t>
+              <a:t>  orchestration, 5 seeds each</a:t>
             </a:r>
           </a:p>
         </p:txBody>
@@ -9559,8 +9559,8 @@
         </p:nvSpPr>
         <p:spPr>
           <a:xfrm>
-            <a:off x="6583680" y="1737360"/>
-            <a:ext cx="5029200" cy="4206240"/>
+            <a:off x="6309360" y="1645920"/>
+            <a:ext cx="5303520" cy="2651760"/>
           </a:xfrm>
           <a:prstGeom prst="rect">
             <a:avLst/>
@@ -9578,11 +9578,11 @@
                 <a:spcPct val="105000"/>
               </a:lnSpc>
               <a:spcAft>
-                <a:spcPts val="1200"/>
-              </a:spcAft>
-            </a:pPr>
-            <a:r>
-              <a:rPr sz="1500" b="1" i="0">
+                <a:spcPts val="900"/>
+              </a:spcAft>
+            </a:pPr>
+            <a:r>
+              <a:rPr sz="1350" b="1" i="0">
                 <a:solidFill>
                   <a:srgbClr val="1B3A6B"/>
                 </a:solidFill>
@@ -9591,13 +9591,13 @@
               <a:t>The baseline is honest:  </a:t>
             </a:r>
             <a:r>
-              <a:rPr sz="1500" b="0" i="0">
+              <a:rPr sz="1350" b="0" i="0">
                 <a:solidFill>
                   <a:srgbClr val="212121"/>
                 </a:solidFill>
                 <a:latin typeface="Calibri"/>
               </a:rPr>
-              <a:t>an industry-style weight-of-evidence scorecard, not a strawman logistic regression on raw inputs.</a:t>
+              <a:t>an industry-style WoE scorecard, not a strawman logistic regression on raw inputs.</a:t>
             </a:r>
           </a:p>
           <a:p>
@@ -9606,11 +9606,11 @@
                 <a:spcPct val="105000"/>
               </a:lnSpc>
               <a:spcAft>
-                <a:spcPts val="1200"/>
-              </a:spcAft>
-            </a:pPr>
-            <a:r>
-              <a:rPr sz="1500" b="1" i="0">
+                <a:spcPts val="900"/>
+              </a:spcAft>
+            </a:pPr>
+            <a:r>
+              <a:rPr sz="1350" b="1" i="0">
                 <a:solidFill>
                   <a:srgbClr val="1B3A6B"/>
                 </a:solidFill>
@@ -9619,13 +9619,13 @@
               <a:t>Same information for everyone:  </a:t>
             </a:r>
             <a:r>
-              <a:rPr sz="1500" b="0" i="0">
+              <a:rPr sz="1350" b="0" i="0">
                 <a:solidFill>
                   <a:srgbClr val="212121"/>
                 </a:solidFill>
                 <a:latin typeface="Calibri"/>
               </a:rPr>
-              <a:t>all four models see the identical 23 origination-time features; preprocessing differences cannot explain gaps.</a:t>
+              <a:t>all four models see the identical 23 features; preprocessing cannot explain the gaps.</a:t>
             </a:r>
           </a:p>
           <a:p>
@@ -9634,54 +9634,361 @@
                 <a:spcPct val="105000"/>
               </a:lnSpc>
               <a:spcAft>
-                <a:spcPts val="1200"/>
-              </a:spcAft>
-            </a:pPr>
-            <a:r>
-              <a:rPr sz="1500" b="1" i="0">
+                <a:spcPts val="900"/>
+              </a:spcAft>
+            </a:pPr>
+            <a:r>
+              <a:rPr sz="1350" b="1" i="0">
                 <a:solidFill>
                   <a:srgbClr val="1B3A6B"/>
                 </a:solidFill>
                 <a:latin typeface="Calibri"/>
               </a:rPr>
-              <a:t>Calibration is separated from fitting:  </a:t>
-            </a:r>
-            <a:r>
-              <a:rPr sz="1500" b="0" i="0">
+              <a:t>Calibration is separated from fitting  </a:t>
+            </a:r>
+            <a:r>
+              <a:rPr sz="1350" b="0" i="0">
                 <a:solidFill>
                   <a:srgbClr val="212121"/>
                 </a:solidFill>
                 <a:latin typeface="Calibri"/>
               </a:rPr>
-              <a:t>every model is recalibrated the same way on the validation vintage, mimicking bank practice.</a:t>
-            </a:r>
-          </a:p>
-          <a:p>
-            <a:pPr algn="l">
-              <a:lnSpc>
-                <a:spcPct val="105000"/>
-              </a:lnSpc>
-              <a:spcAft>
-                <a:spcPts val="1200"/>
-              </a:spcAft>
-            </a:pPr>
-            <a:r>
-              <a:rPr sz="1500" b="1" i="0">
+              <a:t>and profit uses real cash flows: repaid loans earn their interest, charged-off lose 65% of principal.</a:t>
+            </a:r>
+          </a:p>
+        </p:txBody>
+      </p:sp>
+      <p:sp>
+        <p:nvSpPr>
+          <p:cNvPr id="8" name="Rounded Rectangle 7"/>
+          <p:cNvSpPr/>
+          <p:nvPr/>
+        </p:nvSpPr>
+        <p:spPr>
+          <a:xfrm>
+            <a:off x="548640" y="4480560"/>
+            <a:ext cx="5394960" cy="2103120"/>
+          </a:xfrm>
+          <a:prstGeom prst="roundRect">
+            <a:avLst>
+              <a:gd name="adj" fmla="val 8000"/>
+            </a:avLst>
+          </a:prstGeom>
+          <a:solidFill>
+            <a:srgbClr val="EDF1F7"/>
+          </a:solidFill>
+          <a:ln>
+            <a:noFill/>
+          </a:ln>
+          <a:effectLst/>
+        </p:spPr>
+        <p:style>
+          <a:lnRef idx="1">
+            <a:schemeClr val="accent1"/>
+          </a:lnRef>
+          <a:fillRef idx="3">
+            <a:schemeClr val="accent1"/>
+          </a:fillRef>
+          <a:effectRef idx="2">
+            <a:schemeClr val="accent1"/>
+          </a:effectRef>
+          <a:fontRef idx="minor">
+            <a:schemeClr val="lt1"/>
+          </a:fontRef>
+        </p:style>
+        <p:txBody>
+          <a:bodyPr rtlCol="0" anchor="ctr"/>
+          <a:lstStyle/>
+          <a:p>
+            <a:pPr algn="ctr"/>
+          </a:p>
+        </p:txBody>
+      </p:sp>
+      <p:sp>
+        <p:nvSpPr>
+          <p:cNvPr id="9" name="TextBox 8"/>
+          <p:cNvSpPr txBox="1"/>
+          <p:nvPr/>
+        </p:nvSpPr>
+        <p:spPr>
+          <a:xfrm>
+            <a:off x="822960" y="4617720"/>
+            <a:ext cx="4846320" cy="320040"/>
+          </a:xfrm>
+          <a:prstGeom prst="rect">
+            <a:avLst/>
+          </a:prstGeom>
+          <a:noFill/>
+        </p:spPr>
+        <p:txBody>
+          <a:bodyPr wrap="square" anchor="t" lIns="0" rIns="0" tIns="0" bIns="0">
+            <a:spAutoFit/>
+          </a:bodyPr>
+          <a:lstStyle/>
+          <a:p>
+            <a:pPr algn="l">
+              <a:lnSpc>
+                <a:spcPct val="100000"/>
+              </a:lnSpc>
+              <a:spcAft>
+                <a:spcPts val="600"/>
+              </a:spcAft>
+            </a:pPr>
+            <a:r>
+              <a:rPr sz="1450" b="1" i="0">
                 <a:solidFill>
                   <a:srgbClr val="1B3A6B"/>
                 </a:solidFill>
                 <a:latin typeface="Calibri"/>
               </a:rPr>
-              <a:t>Profit uses real cash flows:  </a:t>
-            </a:r>
-            <a:r>
-              <a:rPr sz="1500" b="0" i="0">
+              <a:t>Kept: 23 origination-time fields</a:t>
+            </a:r>
+          </a:p>
+        </p:txBody>
+      </p:sp>
+      <p:sp>
+        <p:nvSpPr>
+          <p:cNvPr id="10" name="TextBox 9"/>
+          <p:cNvSpPr txBox="1"/>
+          <p:nvPr/>
+        </p:nvSpPr>
+        <p:spPr>
+          <a:xfrm>
+            <a:off x="822960" y="4983480"/>
+            <a:ext cx="4846320" cy="1463040"/>
+          </a:xfrm>
+          <a:prstGeom prst="rect">
+            <a:avLst/>
+          </a:prstGeom>
+          <a:noFill/>
+        </p:spPr>
+        <p:txBody>
+          <a:bodyPr wrap="square" anchor="t" lIns="0" rIns="0" tIns="0" bIns="0">
+            <a:spAutoFit/>
+          </a:bodyPr>
+          <a:lstStyle/>
+          <a:p>
+            <a:pPr algn="l">
+              <a:lnSpc>
+                <a:spcPct val="100000"/>
+              </a:lnSpc>
+              <a:spcAft>
+                <a:spcPts val="500"/>
+              </a:spcAft>
+            </a:pPr>
+            <a:r>
+              <a:rPr sz="1150" b="0" i="0">
                 <a:solidFill>
                   <a:srgbClr val="212121"/>
                 </a:solidFill>
                 <a:latin typeface="Calibri"/>
               </a:rPr>
-              <a:t>repaid loans earn their actual interest; charged-off loans lose 65% of principal.</a:t>
+              <a:t>loan_amnt · term · int_rate · installment · grade · sub_grade</a:t>
+            </a:r>
+          </a:p>
+          <a:p>
+            <a:pPr algn="l">
+              <a:lnSpc>
+                <a:spcPct val="100000"/>
+              </a:lnSpc>
+              <a:spcAft>
+                <a:spcPts val="500"/>
+              </a:spcAft>
+            </a:pPr>
+            <a:r>
+              <a:rPr sz="1150" b="0" i="0">
+                <a:solidFill>
+                  <a:srgbClr val="212121"/>
+                </a:solidFill>
+                <a:latin typeface="Calibri"/>
+              </a:rPr>
+              <a:t>annual_inc · dti · emp_length · home_ownership · purpose</a:t>
+            </a:r>
+          </a:p>
+          <a:p>
+            <a:pPr algn="l">
+              <a:lnSpc>
+                <a:spcPct val="100000"/>
+              </a:lnSpc>
+              <a:spcAft>
+                <a:spcPts val="500"/>
+              </a:spcAft>
+            </a:pPr>
+            <a:r>
+              <a:rPr sz="1150" b="0" i="0">
+                <a:solidFill>
+                  <a:srgbClr val="212121"/>
+                </a:solidFill>
+                <a:latin typeface="Calibri"/>
+              </a:rPr>
+              <a:t>fico · revol_util · inq_last_6mths · delinq_2yrs · open_acc · revol_bal · total_acc · mort_acc · pub_rec</a:t>
+            </a:r>
+          </a:p>
+        </p:txBody>
+      </p:sp>
+      <p:sp>
+        <p:nvSpPr>
+          <p:cNvPr id="11" name="Rounded Rectangle 10"/>
+          <p:cNvSpPr/>
+          <p:nvPr/>
+        </p:nvSpPr>
+        <p:spPr>
+          <a:xfrm>
+            <a:off x="6309360" y="4480560"/>
+            <a:ext cx="5303520" cy="2103120"/>
+          </a:xfrm>
+          <a:prstGeom prst="roundRect">
+            <a:avLst>
+              <a:gd name="adj" fmla="val 8000"/>
+            </a:avLst>
+          </a:prstGeom>
+          <a:solidFill>
+            <a:srgbClr val="EDF1F7"/>
+          </a:solidFill>
+          <a:ln>
+            <a:noFill/>
+          </a:ln>
+          <a:effectLst/>
+        </p:spPr>
+        <p:style>
+          <a:lnRef idx="1">
+            <a:schemeClr val="accent1"/>
+          </a:lnRef>
+          <a:fillRef idx="3">
+            <a:schemeClr val="accent1"/>
+          </a:fillRef>
+          <a:effectRef idx="2">
+            <a:schemeClr val="accent1"/>
+          </a:effectRef>
+          <a:fontRef idx="minor">
+            <a:schemeClr val="lt1"/>
+          </a:fontRef>
+        </p:style>
+        <p:txBody>
+          <a:bodyPr rtlCol="0" anchor="ctr"/>
+          <a:lstStyle/>
+          <a:p>
+            <a:pPr algn="ctr"/>
+          </a:p>
+        </p:txBody>
+      </p:sp>
+      <p:sp>
+        <p:nvSpPr>
+          <p:cNvPr id="12" name="TextBox 11"/>
+          <p:cNvSpPr txBox="1"/>
+          <p:nvPr/>
+        </p:nvSpPr>
+        <p:spPr>
+          <a:xfrm>
+            <a:off x="6583680" y="4617720"/>
+            <a:ext cx="4754880" cy="320040"/>
+          </a:xfrm>
+          <a:prstGeom prst="rect">
+            <a:avLst/>
+          </a:prstGeom>
+          <a:noFill/>
+        </p:spPr>
+        <p:txBody>
+          <a:bodyPr wrap="square" anchor="t" lIns="0" rIns="0" tIns="0" bIns="0">
+            <a:spAutoFit/>
+          </a:bodyPr>
+          <a:lstStyle/>
+          <a:p>
+            <a:pPr algn="l">
+              <a:lnSpc>
+                <a:spcPct val="100000"/>
+              </a:lnSpc>
+              <a:spcAft>
+                <a:spcPts val="600"/>
+              </a:spcAft>
+            </a:pPr>
+            <a:r>
+              <a:rPr sz="1450" b="1" i="0">
+                <a:solidFill>
+                  <a:srgbClr val="A42A2A"/>
+                </a:solidFill>
+                <a:latin typeface="Calibri"/>
+              </a:rPr>
+              <a:t>Discarded: 128 columns</a:t>
+            </a:r>
+          </a:p>
+        </p:txBody>
+      </p:sp>
+      <p:sp>
+        <p:nvSpPr>
+          <p:cNvPr id="13" name="TextBox 12"/>
+          <p:cNvSpPr txBox="1"/>
+          <p:nvPr/>
+        </p:nvSpPr>
+        <p:spPr>
+          <a:xfrm>
+            <a:off x="6583680" y="4983480"/>
+            <a:ext cx="4754880" cy="1463040"/>
+          </a:xfrm>
+          <a:prstGeom prst="rect">
+            <a:avLst/>
+          </a:prstGeom>
+          <a:noFill/>
+        </p:spPr>
+        <p:txBody>
+          <a:bodyPr wrap="square" anchor="t" lIns="0" rIns="0" tIns="0" bIns="0">
+            <a:spAutoFit/>
+          </a:bodyPr>
+          <a:lstStyle/>
+          <a:p>
+            <a:pPr algn="l">
+              <a:lnSpc>
+                <a:spcPct val="100000"/>
+              </a:lnSpc>
+              <a:spcAft>
+                <a:spcPts val="600"/>
+              </a:spcAft>
+            </a:pPr>
+            <a:r>
+              <a:rPr sz="1150" b="0" i="0">
+                <a:solidFill>
+                  <a:srgbClr val="212121"/>
+                </a:solidFill>
+                <a:latin typeface="Calibri"/>
+              </a:rPr>
+              <a:t>total_pymnt · total_rec_prncp · recoveries · collection_recovery_fee · last_pymnt_amnt · last_fico_range_high</a:t>
+            </a:r>
+          </a:p>
+          <a:p>
+            <a:pPr algn="l">
+              <a:lnSpc>
+                <a:spcPct val="100000"/>
+              </a:lnSpc>
+              <a:spcAft>
+                <a:spcPts val="600"/>
+              </a:spcAft>
+            </a:pPr>
+            <a:r>
+              <a:rPr sz="1150" b="0" i="1">
+                <a:solidFill>
+                  <a:srgbClr val="212121"/>
+                </a:solidFill>
+                <a:latin typeface="Calibri"/>
+              </a:rPr>
+              <a:t>Known only after the loan was funded. </a:t>
+            </a:r>
+            <a:r>
+              <a:rPr sz="1150" b="1" i="0">
+                <a:solidFill>
+                  <a:srgbClr val="1B3A6B"/>
+                </a:solidFill>
+                <a:latin typeface="Calibri"/>
+              </a:rPr>
+              <a:t>total_rec_prncp</a:t>
+            </a:r>
+            <a:r>
+              <a:rPr sz="1150" b="0" i="1">
+                <a:solidFill>
+                  <a:srgbClr val="212121"/>
+                </a:solidFill>
+                <a:latin typeface="Calibri"/>
+              </a:rPr>
+              <a:t> equals the loan amount for every repaid loan: it is the answer, not a feature.</a:t>
             </a:r>
           </a:p>
         </p:txBody>

</xml_diff>

<commit_message>
Correct the FICO floor to 662 and expand acronyms on first use
The sample minimum of 612 comes from 603 loans in the 2007 vintage;
from 2009 the minimum is exactly 662 in every vintage, which is an
approval cutoff. Report, deck and voiceover now say so.

AUC, FICO, DTI and KS are spelled out where each first appears, and
the voiceover uses numerals with thousands separators throughout
rather than words, so figures are quicker to read off the page.

Co-Authored-By: Claude Opus 4.8 <noreply@anthropic.com>
</commit_message>
<xml_diff>
--- a/report_and_video/Project_Video_Presentation.pptx
+++ b/report_and_video/Project_Video_Presentation.pptx
@@ -1004,7 +1004,7 @@
           <a:lstStyle/>
           <a:p>
             <a:r>
-              <a:t>Dataset: public Lending Club loans, and worth a moment on what they actually are. Small unsecured consumer loans, median ten thousand dollars over three years, mostly people refinancing more expensive credit-card debt. Note the FICO floor of 612: Lending Club had already screened everyone, which is why that field discriminates so weakly and why the achievable AUCs sit near 0.68. Then the two key decisions: the origination-time whitelist against leakage, and the out-of-time vintage split.</a:t>
+              <a:t>Dataset: public Lending Club loans, and worth a moment on what they actually are. Small unsecured consumer loans, median ten thousand dollars over three years, mostly people refinancing more expensive credit-card debt. Note the FICO floor: from 2009 the minimum score in every single vintage is exactly 662, which is an approval cutoff, not a coincidence. Nobody genuinely subprime is in this sample, which is part of why the achievable AUCs sit near 0.68. Then the two key decisions: the origination-time whitelist against leakage, and the out-of-time vintage split.</a:t>
             </a:r>
           </a:p>
         </p:txBody>
@@ -6734,7 +6734,7 @@
                 </a:solidFill>
                 <a:latin typeface="Calibri"/>
               </a:rPr>
-              <a:t>benchmarking papers report boosted trees dominate, but they score models almost exclusively by AUC.</a:t>
+              <a:t>benchmarking papers report boosted trees dominate, but they score models almost exclusively by AUC, the area under the ROC curve.</a:t>
             </a:r>
           </a:p>
           <a:p>
@@ -6892,7 +6892,7 @@
                 </a:solidFill>
                 <a:latin typeface="Calibri"/>
               </a:rPr>
-              <a:t>Can the model rank bad borrowers above good ones? (AUC, KS)</a:t>
+              <a:t>Can the model rank bad borrowers above good ones? (area under the ROC curve, AUC; and KS)</a:t>
             </a:r>
           </a:p>
         </p:txBody>
@@ -8755,7 +8755,7 @@
                 </a:solidFill>
                 <a:latin typeface="Calibri"/>
               </a:rPr>
-              <a:t>median income $60,000, DTI 17%, 15 years of credit history</a:t>
+              <a:t>median income $60,000, debt-to-income ratio 17%</a:t>
             </a:r>
           </a:p>
         </p:txBody>
@@ -9049,7 +9049,7 @@
                 </a:solidFill>
                 <a:latin typeface="Calibri"/>
               </a:rPr>
-              <a:t>FICO floor 612, median 692:  </a:t>
+              <a:t>FICO credit score:  </a:t>
             </a:r>
             <a:r>
               <a:rPr sz="1250" b="0" i="0">
@@ -9058,7 +9058,7 @@
                 </a:solidFill>
                 <a:latin typeface="Calibri"/>
               </a:rPr>
-              <a:t>a narrow band, by design</a:t>
+              <a:t>floor 662, median 692, an approval cutoff</a:t>
             </a:r>
           </a:p>
         </p:txBody>
@@ -10220,7 +10220,7 @@
                 </a:solidFill>
                 <a:latin typeface="Calibri"/>
               </a:rPr>
-              <a:t>AUC: probability a random defaulter is ranked riskier than a random good borrower. KS: maximum distance between the two score distributions. Both ignore whether the PD values themselves are right.</a:t>
+              <a:t>AUC, the area under the receiver operating characteristic curve: the probability a random defaulter is ranked riskier than a random good borrower. KS, Kolmogorov-Smirnov: the maximum distance between the two score distributions. Both ignore whether the PD values themselves are right.</a:t>
             </a:r>
           </a:p>
         </p:txBody>

</xml_diff>